<commit_message>
Lesson sd-10-012: explain the Bloom filter from the Apache Spark sources and in the lesson's own words for the three options, with the figure, metadata and deck
Co-Authored-By: Claude Sonnet 5.5 <noreply@anthropic.com>
Claude-Session: https://claude.ai/code/session_011dmt3ZFdN8sjiTfDnyUVN7
</commit_message>
<xml_diff>
--- a/system-design-101/vi/lessons/sd-10-012/slides/sd-10-012.pptx
+++ b/system-design-101/vi/lessons/sd-10-012/slides/sd-10-012.pptx
@@ -3304,7 +3304,7 @@
               <a:buNone/>
             </a:pPr>
             <a:r>
-              <a:rPr lang="en-US" sz="5700" dirty="0" spc="-62" kern="0">
+              <a:rPr lang="en-US" sz="5700" dirty="0" spc="5" kern="0">
                 <a:solidFill>
                   <a:srgbClr val="7C93FF"/>
                 </a:solidFill>
@@ -3312,7 +3312,7 @@
                 <a:ea typeface="Bricolage Grotesque ExtraBold" pitchFamily="34" charset="-122"/>
                 <a:cs typeface="Bricolage Grotesque ExtraBold" pitchFamily="34" charset="-120"/>
               </a:rPr>
-              <a:t>1970</a:t>
+              <a:t>1</a:t>
             </a:r>
             <a:endParaRPr lang="en-US" sz="5700" dirty="0"/>
           </a:p>
@@ -3346,7 +3346,7 @@
               <a:buNone/>
             </a:pPr>
             <a:r>
-              <a:rPr lang="en-US" sz="1800" dirty="0" spc="-4" kern="0">
+              <a:rPr lang="en-US" sz="1800" dirty="0" spc="0" kern="0">
                 <a:solidFill>
                   <a:srgbClr val="C4C8D6"/>
                 </a:solidFill>
@@ -3354,10 +3354,10 @@
                 <a:ea typeface="Be Vietnam Pro" pitchFamily="34" charset="-122"/>
                 <a:cs typeface="Be Vietnam Pro" pitchFamily="34" charset="-120"/>
               </a:rPr>
-              <a:t>năm</a:t>
-            </a:r>
-            <a:r>
-              <a:rPr lang="en-US" sz="1800" dirty="0" spc="-1" kern="0">
+              <a:t>phía</a:t>
+            </a:r>
+            <a:r>
+              <a:rPr lang="en-US" sz="1800" dirty="0" spc="-2" kern="0">
                 <a:solidFill>
                   <a:srgbClr val="C4C8D6"/>
                 </a:solidFill>
@@ -3365,7 +3365,7 @@
                 <a:ea typeface="Be Vietnam Pro" pitchFamily="34" charset="-122"/>
                 <a:cs typeface="Be Vietnam Pro" pitchFamily="34" charset="-120"/>
               </a:rPr>
-              <a:t> Bloom</a:t>
+              <a:t> sai</a:t>
             </a:r>
             <a:endParaRPr lang="en-US" sz="1800" dirty="0"/>
           </a:p>
@@ -3377,7 +3377,7 @@
               <a:buNone/>
             </a:pPr>
             <a:r>
-              <a:rPr lang="en-US" sz="1800" dirty="0" spc="18" kern="0">
+              <a:rPr lang="en-US" sz="1800" dirty="0" spc="-3" kern="0">
                 <a:solidFill>
                   <a:srgbClr val="C4C8D6"/>
                 </a:solidFill>
@@ -3385,10 +3385,10 @@
                 <a:ea typeface="Be Vietnam Pro" pitchFamily="34" charset="-122"/>
                 <a:cs typeface="Be Vietnam Pro" pitchFamily="34" charset="-120"/>
               </a:rPr>
-              <a:t>đề</a:t>
-            </a:r>
-            <a:r>
-              <a:rPr lang="en-US" sz="1800" dirty="0" spc="-8" kern="0">
+              <a:t>duy</a:t>
+            </a:r>
+            <a:r>
+              <a:rPr lang="en-US" sz="1800" dirty="0" spc="-9" kern="0">
                 <a:solidFill>
                   <a:srgbClr val="C4C8D6"/>
                 </a:solidFill>
@@ -3396,7 +3396,7 @@
                 <a:ea typeface="Be Vietnam Pro" pitchFamily="34" charset="-122"/>
                 <a:cs typeface="Be Vietnam Pro" pitchFamily="34" charset="-120"/>
               </a:rPr>
-              <a:t> xuất</a:t>
+              <a:t> nhất</a:t>
             </a:r>
             <a:endParaRPr lang="en-US" sz="1800" dirty="0"/>
           </a:p>
@@ -5922,48 +5922,48 @@
               <a:buNone/>
             </a:pPr>
             <a:r>
-              <a:rPr lang="en-US" sz="2250" b="1" dirty="0" spc="13" kern="0">
-                <a:solidFill>
-                  <a:srgbClr val="14161C"/>
-                </a:solidFill>
-                <a:latin typeface="Be Vietnam Pro" pitchFamily="34" charset="0"/>
-                <a:ea typeface="Be Vietnam Pro" pitchFamily="34" charset="-122"/>
-                <a:cs typeface="Be Vietnam Pro" pitchFamily="34" charset="-120"/>
-              </a:rPr>
-              <a:t>Được</a:t>
-            </a:r>
-            <a:r>
-              <a:rPr lang="en-US" sz="2250" b="1" dirty="0" spc="-5" kern="0">
-                <a:solidFill>
-                  <a:srgbClr val="14161C"/>
-                </a:solidFill>
-                <a:latin typeface="Be Vietnam Pro" pitchFamily="34" charset="0"/>
-                <a:ea typeface="Be Vietnam Pro" pitchFamily="34" charset="-122"/>
-                <a:cs typeface="Be Vietnam Pro" pitchFamily="34" charset="-120"/>
-              </a:rPr>
-              <a:t> nguồn</a:t>
-            </a:r>
-            <a:r>
-              <a:rPr lang="en-US" sz="2250" b="1" dirty="0" spc="39" kern="0">
-                <a:solidFill>
-                  <a:srgbClr val="14161C"/>
-                </a:solidFill>
-                <a:latin typeface="Be Vietnam Pro" pitchFamily="34" charset="0"/>
-                <a:ea typeface="Be Vietnam Pro" pitchFamily="34" charset="-122"/>
-                <a:cs typeface="Be Vietnam Pro" pitchFamily="34" charset="-120"/>
-              </a:rPr>
-              <a:t> ưu</a:t>
-            </a:r>
-            <a:r>
-              <a:rPr lang="en-US" sz="2250" b="1" dirty="0" spc="-1" kern="0">
-                <a:solidFill>
-                  <a:srgbClr val="14161C"/>
-                </a:solidFill>
-                <a:latin typeface="Be Vietnam Pro" pitchFamily="34" charset="0"/>
-                <a:ea typeface="Be Vietnam Pro" pitchFamily="34" charset="-122"/>
-                <a:cs typeface="Be Vietnam Pro" pitchFamily="34" charset="-120"/>
-              </a:rPr>
-              <a:t> tiên:</a:t>
+              <a:rPr lang="en-US" sz="2250" b="1" dirty="0" spc="4" kern="0">
+                <a:solidFill>
+                  <a:srgbClr val="14161C"/>
+                </a:solidFill>
+                <a:latin typeface="Be Vietnam Pro" pitchFamily="34" charset="0"/>
+                <a:ea typeface="Be Vietnam Pro" pitchFamily="34" charset="-122"/>
+                <a:cs typeface="Be Vietnam Pro" pitchFamily="34" charset="-120"/>
+              </a:rPr>
+              <a:t>Chủ</a:t>
+            </a:r>
+            <a:r>
+              <a:rPr lang="en-US" sz="2250" b="1" dirty="0" spc="9" kern="0">
+                <a:solidFill>
+                  <a:srgbClr val="14161C"/>
+                </a:solidFill>
+                <a:latin typeface="Be Vietnam Pro" pitchFamily="34" charset="0"/>
+                <a:ea typeface="Be Vietnam Pro" pitchFamily="34" charset="-122"/>
+                <a:cs typeface="Be Vietnam Pro" pitchFamily="34" charset="-120"/>
+              </a:rPr>
+              <a:t> đề</a:t>
+            </a:r>
+            <a:r>
+              <a:rPr lang="en-US" sz="2250" b="1" dirty="0" spc="4" kern="0">
+                <a:solidFill>
+                  <a:srgbClr val="14161C"/>
+                </a:solidFill>
+                <a:latin typeface="Be Vietnam Pro" pitchFamily="34" charset="0"/>
+                <a:ea typeface="Be Vietnam Pro" pitchFamily="34" charset="-122"/>
+                <a:cs typeface="Be Vietnam Pro" pitchFamily="34" charset="-120"/>
+              </a:rPr>
+              <a:t> của</a:t>
+            </a:r>
+            <a:r>
+              <a:rPr lang="en-US" sz="2250" b="1" dirty="0" spc="3" kern="0">
+                <a:solidFill>
+                  <a:srgbClr val="14161C"/>
+                </a:solidFill>
+                <a:latin typeface="Be Vietnam Pro" pitchFamily="34" charset="0"/>
+                <a:ea typeface="Be Vietnam Pro" pitchFamily="34" charset="-122"/>
+                <a:cs typeface="Be Vietnam Pro" pitchFamily="34" charset="-120"/>
+              </a:rPr>
+              <a:t> bài:</a:t>
             </a:r>
             <a:r>
               <a:rPr lang="en-US" sz="2250" b="1" dirty="0" spc="4" kern="0">
@@ -6410,6 +6410,50 @@
               <a:buNone/>
             </a:pPr>
             <a:r>
+              <a:rPr lang="en-US" sz="2400" dirty="0" spc="2" kern="0">
+                <a:solidFill>
+                  <a:srgbClr val="C4C8D6"/>
+                </a:solidFill>
+                <a:latin typeface="Be Vietnam Pro" pitchFamily="34" charset="0"/>
+                <a:ea typeface="Be Vietnam Pro" pitchFamily="34" charset="-122"/>
+                <a:cs typeface="Be Vietnam Pro" pitchFamily="34" charset="-120"/>
+              </a:rPr>
+              <a:t>Giữ</a:t>
+            </a:r>
+            <a:r>
+              <a:rPr lang="en-US" sz="2400" dirty="0" spc="-12" kern="0">
+                <a:solidFill>
+                  <a:srgbClr val="C4C8D6"/>
+                </a:solidFill>
+                <a:latin typeface="Be Vietnam Pro" pitchFamily="34" charset="0"/>
+                <a:ea typeface="Be Vietnam Pro" pitchFamily="34" charset="-122"/>
+                <a:cs typeface="Be Vietnam Pro" pitchFamily="34" charset="-120"/>
+              </a:rPr>
+              <a:t> nguyên</a:t>
+            </a:r>
+            <a:r>
+              <a:rPr lang="en-US" sz="2400" dirty="0" spc="2" kern="0">
+                <a:solidFill>
+                  <a:srgbClr val="C4C8D6"/>
+                </a:solidFill>
+                <a:latin typeface="Be Vietnam Pro" pitchFamily="34" charset="0"/>
+                <a:ea typeface="Be Vietnam Pro" pitchFamily="34" charset="-122"/>
+                <a:cs typeface="Be Vietnam Pro" pitchFamily="34" charset="-120"/>
+              </a:rPr>
+              <a:t> mọi</a:t>
+            </a:r>
+            <a:r>
+              <a:rPr lang="en-US" sz="2400" dirty="0" spc="26" kern="0">
+                <a:solidFill>
+                  <a:srgbClr val="C4C8D6"/>
+                </a:solidFill>
+                <a:latin typeface="Be Vietnam Pro" pitchFamily="34" charset="0"/>
+                <a:ea typeface="Be Vietnam Pro" pitchFamily="34" charset="-122"/>
+                <a:cs typeface="Be Vietnam Pro" pitchFamily="34" charset="-120"/>
+              </a:rPr>
+              <a:t> địa</a:t>
+            </a:r>
+            <a:r>
               <a:rPr lang="en-US" sz="2400" dirty="0" spc="0" kern="0">
                 <a:solidFill>
                   <a:srgbClr val="C4C8D6"/>
@@ -6418,29 +6462,7 @@
                 <a:ea typeface="Be Vietnam Pro" pitchFamily="34" charset="-122"/>
                 <a:cs typeface="Be Vietnam Pro" pitchFamily="34" charset="-120"/>
               </a:rPr>
-              <a:t>Nhanh,</a:t>
-            </a:r>
-            <a:r>
-              <a:rPr lang="en-US" sz="2400" dirty="0" spc="16" kern="0">
-                <a:solidFill>
-                  <a:srgbClr val="C4C8D6"/>
-                </a:solidFill>
-                <a:latin typeface="Be Vietnam Pro" pitchFamily="34" charset="0"/>
-                <a:ea typeface="Be Vietnam Pro" pitchFamily="34" charset="-122"/>
-                <a:cs typeface="Be Vietnam Pro" pitchFamily="34" charset="-120"/>
-              </a:rPr>
-              <a:t> nhưng</a:t>
-            </a:r>
-            <a:r>
-              <a:rPr lang="en-US" sz="2400" dirty="0" spc="1" kern="0">
-                <a:solidFill>
-                  <a:srgbClr val="C4C8D6"/>
-                </a:solidFill>
-                <a:latin typeface="Be Vietnam Pro" pitchFamily="34" charset="0"/>
-                <a:ea typeface="Be Vietnam Pro" pitchFamily="34" charset="-122"/>
-                <a:cs typeface="Be Vietnam Pro" pitchFamily="34" charset="-120"/>
-              </a:rPr>
-              <a:t> không</a:t>
+              <a:t> chỉ,</a:t>
             </a:r>
             <a:endParaRPr lang="en-US" sz="2400" dirty="0"/>
           </a:p>
@@ -6452,7 +6474,7 @@
               <a:buNone/>
             </a:pPr>
             <a:r>
-              <a:rPr lang="en-US" sz="2400" dirty="0" spc="-6" kern="0">
+              <a:rPr lang="en-US" sz="2400" dirty="0" spc="0" kern="0">
                 <a:solidFill>
                   <a:srgbClr val="C4C8D6"/>
                 </a:solidFill>
@@ -6460,10 +6482,10 @@
                 <a:ea typeface="Be Vietnam Pro" pitchFamily="34" charset="-122"/>
                 <a:cs typeface="Be Vietnam Pro" pitchFamily="34" charset="-120"/>
               </a:rPr>
-              <a:t>tiết</a:t>
-            </a:r>
-            <a:r>
-              <a:rPr lang="en-US" sz="2400" dirty="0" spc="-1" kern="0">
+              <a:t>nên</a:t>
+            </a:r>
+            <a:r>
+              <a:rPr lang="en-US" sz="2400" dirty="0" spc="-10" kern="0">
                 <a:solidFill>
                   <a:srgbClr val="C4C8D6"/>
                 </a:solidFill>
@@ -6471,7 +6493,18 @@
                 <a:ea typeface="Be Vietnam Pro" pitchFamily="34" charset="-122"/>
                 <a:cs typeface="Be Vietnam Pro" pitchFamily="34" charset="-120"/>
               </a:rPr>
-              <a:t> kiệm bộ</a:t>
+              <a:t> tốn</a:t>
+            </a:r>
+            <a:r>
+              <a:rPr lang="en-US" sz="2400" dirty="0" spc="-2" kern="0">
+                <a:solidFill>
+                  <a:srgbClr val="C4C8D6"/>
+                </a:solidFill>
+                <a:latin typeface="Be Vietnam Pro" pitchFamily="34" charset="0"/>
+                <a:ea typeface="Be Vietnam Pro" pitchFamily="34" charset="-122"/>
+                <a:cs typeface="Be Vietnam Pro" pitchFamily="34" charset="-120"/>
+              </a:rPr>
+              <a:t> bộ</a:t>
             </a:r>
             <a:r>
               <a:rPr lang="en-US" sz="2400" dirty="0" spc="0" kern="0">
@@ -6658,7 +6691,7 @@
               <a:buNone/>
             </a:pPr>
             <a:r>
-              <a:rPr lang="en-US" sz="2400" dirty="0" spc="-9" kern="0">
+              <a:rPr lang="en-US" sz="2400" dirty="0" spc="-1" kern="0">
                 <a:solidFill>
                   <a:srgbClr val="C4C8D6"/>
                 </a:solidFill>
@@ -6666,10 +6699,10 @@
                 <a:ea typeface="Be Vietnam Pro" pitchFamily="34" charset="-122"/>
                 <a:cs typeface="Be Vietnam Pro" pitchFamily="34" charset="-120"/>
               </a:rPr>
-              <a:t>Chạy</a:t>
-            </a:r>
-            <a:r>
-              <a:rPr lang="en-US" sz="2400" dirty="0" spc="6" kern="0">
+              <a:t>Mỗi</a:t>
+            </a:r>
+            <a:r>
+              <a:rPr lang="en-US" sz="2400" dirty="0" spc="1" kern="0">
                 <a:solidFill>
                   <a:srgbClr val="C4C8D6"/>
                 </a:solidFill>
@@ -6677,10 +6710,10 @@
                 <a:ea typeface="Be Vietnam Pro" pitchFamily="34" charset="-122"/>
                 <a:cs typeface="Be Vietnam Pro" pitchFamily="34" charset="-120"/>
               </a:rPr>
-              <a:t> được,</a:t>
-            </a:r>
-            <a:r>
-              <a:rPr lang="en-US" sz="2400" dirty="0" spc="16" kern="0">
+              <a:t> lần</a:t>
+            </a:r>
+            <a:r>
+              <a:rPr lang="en-US" sz="2400" dirty="0" spc="0" kern="0">
                 <a:solidFill>
                   <a:srgbClr val="C4C8D6"/>
                 </a:solidFill>
@@ -6688,10 +6721,10 @@
                 <a:ea typeface="Be Vietnam Pro" pitchFamily="34" charset="-122"/>
                 <a:cs typeface="Be Vietnam Pro" pitchFamily="34" charset="-120"/>
               </a:rPr>
-              <a:t> nhưng</a:t>
-            </a:r>
-            <a:r>
-              <a:rPr lang="en-US" sz="2400" dirty="0" spc="-10" kern="0">
+              <a:t> hỏi</a:t>
+            </a:r>
+            <a:r>
+              <a:rPr lang="en-US" sz="2400" dirty="0" spc="2" kern="0">
                 <a:solidFill>
                   <a:srgbClr val="C4C8D6"/>
                 </a:solidFill>
@@ -6699,18 +6732,7 @@
                 <a:ea typeface="Be Vietnam Pro" pitchFamily="34" charset="-122"/>
                 <a:cs typeface="Be Vietnam Pro" pitchFamily="34" charset="-120"/>
               </a:rPr>
-              <a:t> tải</a:t>
-            </a:r>
-            <a:r>
-              <a:rPr lang="en-US" sz="2400" dirty="0" spc="0" kern="0">
-                <a:solidFill>
-                  <a:srgbClr val="C4C8D6"/>
-                </a:solidFill>
-                <a:latin typeface="Be Vietnam Pro" pitchFamily="34" charset="0"/>
-                <a:ea typeface="Be Vietnam Pro" pitchFamily="34" charset="-122"/>
-                <a:cs typeface="Be Vietnam Pro" pitchFamily="34" charset="-120"/>
-              </a:rPr>
-              <a:t> lên</a:t>
+              <a:t> là</a:t>
             </a:r>
             <a:endParaRPr lang="en-US" sz="2400" dirty="0"/>
           </a:p>
@@ -6722,7 +6744,7 @@
               <a:buNone/>
             </a:pPr>
             <a:r>
-              <a:rPr lang="en-US" sz="2400" dirty="0" spc="0" kern="0">
+              <a:rPr lang="en-US" sz="2400" dirty="0" spc="-5" kern="0">
                 <a:solidFill>
                   <a:srgbClr val="C4C8D6"/>
                 </a:solidFill>
@@ -6730,10 +6752,10 @@
                 <a:ea typeface="Be Vietnam Pro" pitchFamily="34" charset="-122"/>
                 <a:cs typeface="Be Vietnam Pro" pitchFamily="34" charset="-120"/>
               </a:rPr>
-              <a:t>cơ</a:t>
-            </a:r>
-            <a:r>
-              <a:rPr lang="en-US" sz="2400" dirty="0" spc="-9" kern="0">
+              <a:t>một</a:t>
+            </a:r>
+            <a:r>
+              <a:rPr lang="en-US" sz="2400" dirty="0" spc="1" kern="0">
                 <a:solidFill>
                   <a:srgbClr val="C4C8D6"/>
                 </a:solidFill>
@@ -6741,10 +6763,10 @@
                 <a:ea typeface="Be Vietnam Pro" pitchFamily="34" charset="-122"/>
                 <a:cs typeface="Be Vietnam Pro" pitchFamily="34" charset="-120"/>
               </a:rPr>
-              <a:t> sở</a:t>
-            </a:r>
-            <a:r>
-              <a:rPr lang="en-US" sz="2400" dirty="0" spc="4" kern="0">
+              <a:t> truy</a:t>
+            </a:r>
+            <a:r>
+              <a:rPr lang="en-US" sz="2400" dirty="0" spc="-12" kern="0">
                 <a:solidFill>
                   <a:srgbClr val="C4C8D6"/>
                 </a:solidFill>
@@ -6752,10 +6774,10 @@
                 <a:ea typeface="Be Vietnam Pro" pitchFamily="34" charset="-122"/>
                 <a:cs typeface="Be Vietnam Pro" pitchFamily="34" charset="-120"/>
               </a:rPr>
-              <a:t> dữ</a:t>
-            </a:r>
-            <a:r>
-              <a:rPr lang="en-US" sz="2400" dirty="0" spc="-2" kern="0">
+              <a:t> vấn</a:t>
+            </a:r>
+            <a:r>
+              <a:rPr lang="en-US" sz="2400" dirty="0" spc="-29" kern="0">
                 <a:solidFill>
                   <a:srgbClr val="C4C8D6"/>
                 </a:solidFill>
@@ -6763,10 +6785,10 @@
                 <a:ea typeface="Be Vietnam Pro" pitchFamily="34" charset="-122"/>
                 <a:cs typeface="Be Vietnam Pro" pitchFamily="34" charset="-120"/>
               </a:rPr>
-              <a:t> liệu</a:t>
-            </a:r>
-            <a:r>
-              <a:rPr lang="en-US" sz="2400" dirty="0" spc="-33" kern="0">
+              <a:t> ra</a:t>
+            </a:r>
+            <a:r>
+              <a:rPr lang="en-US" sz="2400" dirty="0" spc="-7" kern="0">
                 <a:solidFill>
                   <a:srgbClr val="C4C8D6"/>
                 </a:solidFill>
@@ -6774,18 +6796,7 @@
                 <a:ea typeface="Be Vietnam Pro" pitchFamily="34" charset="-122"/>
                 <a:cs typeface="Be Vietnam Pro" pitchFamily="34" charset="-120"/>
               </a:rPr>
-              <a:t> rất</a:t>
-            </a:r>
-            <a:r>
-              <a:rPr lang="en-US" sz="2400" dirty="0" spc="1" kern="0">
-                <a:solidFill>
-                  <a:srgbClr val="C4C8D6"/>
-                </a:solidFill>
-                <a:latin typeface="Be Vietnam Pro" pitchFamily="34" charset="0"/>
-                <a:ea typeface="Be Vietnam Pro" pitchFamily="34" charset="-122"/>
-                <a:cs typeface="Be Vietnam Pro" pitchFamily="34" charset="-120"/>
-              </a:rPr>
-              <a:t> cao.</a:t>
+              <a:t> ngoài.</a:t>
             </a:r>
             <a:endParaRPr lang="en-US" sz="2400" dirty="0"/>
           </a:p>
@@ -6934,37 +6945,26 @@
               <a:buNone/>
             </a:pPr>
             <a:r>
-              <a:rPr lang="en-US" sz="2400" dirty="0" spc="-1" kern="0">
-                <a:solidFill>
-                  <a:srgbClr val="14161C"/>
-                </a:solidFill>
-                <a:latin typeface="Be Vietnam Pro" pitchFamily="34" charset="0"/>
-                <a:ea typeface="Be Vietnam Pro" pitchFamily="34" charset="-122"/>
-                <a:cs typeface="Be Vietnam Pro" pitchFamily="34" charset="-120"/>
-              </a:rPr>
-              <a:t>Cách</a:t>
-            </a:r>
-            <a:r>
-              <a:rPr lang="en-US" sz="2400" dirty="0" spc="7" kern="0">
-                <a:solidFill>
-                  <a:srgbClr val="14161C"/>
-                </a:solidFill>
-                <a:latin typeface="Be Vietnam Pro" pitchFamily="34" charset="0"/>
-                <a:ea typeface="Be Vietnam Pro" pitchFamily="34" charset="-122"/>
-                <a:cs typeface="Be Vietnam Pro" pitchFamily="34" charset="-120"/>
-              </a:rPr>
-              <a:t> được</a:t>
-            </a:r>
-            <a:r>
-              <a:rPr lang="en-US" sz="2400" dirty="0" spc="21" kern="0">
-                <a:solidFill>
-                  <a:srgbClr val="14161C"/>
-                </a:solidFill>
-                <a:latin typeface="Be Vietnam Pro" pitchFamily="34" charset="0"/>
-                <a:ea typeface="Be Vietnam Pro" pitchFamily="34" charset="-122"/>
-                <a:cs typeface="Be Vietnam Pro" pitchFamily="34" charset="-120"/>
-              </a:rPr>
-              <a:t> ưu</a:t>
+              <a:rPr lang="en-US" sz="2400" dirty="0" spc="-12" kern="0">
+                <a:solidFill>
+                  <a:srgbClr val="14161C"/>
+                </a:solidFill>
+                <a:latin typeface="Be Vietnam Pro" pitchFamily="34" charset="0"/>
+                <a:ea typeface="Be Vietnam Pro" pitchFamily="34" charset="-122"/>
+                <a:cs typeface="Be Vietnam Pro" pitchFamily="34" charset="-120"/>
+              </a:rPr>
+              <a:t>Dãy</a:t>
+            </a:r>
+            <a:r>
+              <a:rPr lang="en-US" sz="2400" dirty="0" spc="1" kern="0">
+                <a:solidFill>
+                  <a:srgbClr val="14161C"/>
+                </a:solidFill>
+                <a:latin typeface="Be Vietnam Pro" pitchFamily="34" charset="0"/>
+                <a:ea typeface="Be Vietnam Pro" pitchFamily="34" charset="-122"/>
+                <a:cs typeface="Be Vietnam Pro" pitchFamily="34" charset="-120"/>
+              </a:rPr>
+              <a:t> bit</a:t>
             </a:r>
             <a:r>
               <a:rPr lang="en-US" sz="2400" dirty="0" spc="0" kern="0">
@@ -6975,18 +6975,29 @@
                 <a:ea typeface="Be Vietnam Pro" pitchFamily="34" charset="-122"/>
                 <a:cs typeface="Be Vietnam Pro" pitchFamily="34" charset="-120"/>
               </a:rPr>
-              <a:t> tiên: cấu</a:t>
-            </a:r>
-            <a:r>
-              <a:rPr lang="en-US" sz="2400" dirty="0" spc="2" kern="0">
-                <a:solidFill>
-                  <a:srgbClr val="14161C"/>
-                </a:solidFill>
-                <a:latin typeface="Be Vietnam Pro" pitchFamily="34" charset="0"/>
-                <a:ea typeface="Be Vietnam Pro" pitchFamily="34" charset="-122"/>
-                <a:cs typeface="Be Vietnam Pro" pitchFamily="34" charset="-120"/>
-              </a:rPr>
-              <a:t> trúc</a:t>
+              <a:t> nhỏ:</a:t>
+            </a:r>
+            <a:r>
+              <a:rPr lang="en-US" sz="2400" dirty="0" spc="1" kern="0">
+                <a:solidFill>
+                  <a:srgbClr val="14161C"/>
+                </a:solidFill>
+                <a:latin typeface="Be Vietnam Pro" pitchFamily="34" charset="0"/>
+                <a:ea typeface="Be Vietnam Pro" pitchFamily="34" charset="-122"/>
+                <a:cs typeface="Be Vietnam Pro" pitchFamily="34" charset="-120"/>
+              </a:rPr>
+              <a:t> có thể</a:t>
+            </a:r>
+            <a:r>
+              <a:rPr lang="en-US" sz="2400" dirty="0" spc="0" kern="0">
+                <a:solidFill>
+                  <a:srgbClr val="14161C"/>
+                </a:solidFill>
+                <a:latin typeface="Be Vietnam Pro" pitchFamily="34" charset="0"/>
+                <a:ea typeface="Be Vietnam Pro" pitchFamily="34" charset="-122"/>
+                <a:cs typeface="Be Vietnam Pro" pitchFamily="34" charset="-120"/>
+              </a:rPr>
+              <a:t> có,</a:t>
             </a:r>
             <a:endParaRPr lang="en-US" sz="2400" dirty="0"/>
           </a:p>
@@ -6998,37 +7009,15 @@
               <a:buNone/>
             </a:pPr>
             <a:r>
-              <a:rPr lang="en-US" sz="2400" dirty="0" spc="-22" kern="0">
-                <a:solidFill>
-                  <a:srgbClr val="14161C"/>
-                </a:solidFill>
-                <a:latin typeface="Be Vietnam Pro" pitchFamily="34" charset="0"/>
-                <a:ea typeface="Be Vietnam Pro" pitchFamily="34" charset="-122"/>
-                <a:cs typeface="Be Vietnam Pro" pitchFamily="34" charset="-120"/>
-              </a:rPr>
-              <a:t>xác</a:t>
-            </a:r>
-            <a:r>
-              <a:rPr lang="en-US" sz="2400" dirty="0" spc="-8" kern="0">
-                <a:solidFill>
-                  <a:srgbClr val="14161C"/>
-                </a:solidFill>
-                <a:latin typeface="Be Vietnam Pro" pitchFamily="34" charset="0"/>
-                <a:ea typeface="Be Vietnam Pro" pitchFamily="34" charset="-122"/>
-                <a:cs typeface="Be Vietnam Pro" pitchFamily="34" charset="-120"/>
-              </a:rPr>
-              <a:t> suất,</a:t>
-            </a:r>
-            <a:r>
-              <a:rPr lang="en-US" sz="2400" dirty="0" spc="-7" kern="0">
-                <a:solidFill>
-                  <a:srgbClr val="14161C"/>
-                </a:solidFill>
-                <a:latin typeface="Be Vietnam Pro" pitchFamily="34" charset="0"/>
-                <a:ea typeface="Be Vietnam Pro" pitchFamily="34" charset="-122"/>
-                <a:cs typeface="Be Vietnam Pro" pitchFamily="34" charset="-120"/>
-              </a:rPr>
-              <a:t> dãy</a:t>
+              <a:rPr lang="en-US" sz="2400" dirty="0" spc="-2" kern="0">
+                <a:solidFill>
+                  <a:srgbClr val="14161C"/>
+                </a:solidFill>
+                <a:latin typeface="Be Vietnam Pro" pitchFamily="34" charset="0"/>
+                <a:ea typeface="Be Vietnam Pro" pitchFamily="34" charset="-122"/>
+                <a:cs typeface="Be Vietnam Pro" pitchFamily="34" charset="-120"/>
+              </a:rPr>
+              <a:t>hoặc</a:t>
             </a:r>
             <a:r>
               <a:rPr lang="en-US" sz="2400" dirty="0" spc="0" kern="0">
@@ -7039,7 +7028,18 @@
                 <a:ea typeface="Be Vietnam Pro" pitchFamily="34" charset="-122"/>
                 <a:cs typeface="Be Vietnam Pro" pitchFamily="34" charset="-120"/>
               </a:rPr>
-              <a:t> bit.</a:t>
+              <a:t> chắc chắn</a:t>
+            </a:r>
+            <a:r>
+              <a:rPr lang="en-US" sz="2400" dirty="0" spc="5" kern="0">
+                <a:solidFill>
+                  <a:srgbClr val="14161C"/>
+                </a:solidFill>
+                <a:latin typeface="Be Vietnam Pro" pitchFamily="34" charset="0"/>
+                <a:ea typeface="Be Vietnam Pro" pitchFamily="34" charset="-122"/>
+                <a:cs typeface="Be Vietnam Pro" pitchFamily="34" charset="-120"/>
+              </a:rPr>
+              <a:t> chưa.</a:t>
             </a:r>
             <a:endParaRPr lang="en-US" sz="2400" dirty="0"/>
           </a:p>
@@ -7776,28 +7776,6 @@
               <a:buNone/>
             </a:pPr>
             <a:r>
-              <a:rPr lang="en-US" sz="2850" dirty="0" spc="-10" kern="0">
-                <a:solidFill>
-                  <a:srgbClr val="14161C"/>
-                </a:solidFill>
-                <a:latin typeface="Be Vietnam Pro" pitchFamily="34" charset="0"/>
-                <a:ea typeface="Be Vietnam Pro" pitchFamily="34" charset="-122"/>
-                <a:cs typeface="Be Vietnam Pro" pitchFamily="34" charset="-120"/>
-              </a:rPr>
-              <a:t>Burton</a:t>
-            </a:r>
-            <a:r>
-              <a:rPr lang="en-US" sz="2850" dirty="0" spc="-30" kern="0">
-                <a:solidFill>
-                  <a:srgbClr val="14161C"/>
-                </a:solidFill>
-                <a:latin typeface="Be Vietnam Pro" pitchFamily="34" charset="0"/>
-                <a:ea typeface="Be Vietnam Pro" pitchFamily="34" charset="-122"/>
-                <a:cs typeface="Be Vietnam Pro" pitchFamily="34" charset="-120"/>
-              </a:rPr>
-              <a:t> Howard</a:t>
-            </a:r>
-            <a:r>
               <a:rPr lang="en-US" sz="2850" dirty="0" spc="-2" kern="0">
                 <a:solidFill>
                   <a:srgbClr val="14161C"/>
@@ -7806,29 +7784,73 @@
                 <a:ea typeface="Be Vietnam Pro" pitchFamily="34" charset="-122"/>
                 <a:cs typeface="Be Vietnam Pro" pitchFamily="34" charset="-120"/>
               </a:rPr>
-              <a:t> Bloom</a:t>
-            </a:r>
-            <a:r>
-              <a:rPr lang="en-US" sz="2850" dirty="0" spc="21" kern="0">
-                <a:solidFill>
-                  <a:srgbClr val="14161C"/>
-                </a:solidFill>
-                <a:latin typeface="Be Vietnam Pro" pitchFamily="34" charset="0"/>
-                <a:ea typeface="Be Vietnam Pro" pitchFamily="34" charset="-122"/>
-                <a:cs typeface="Be Vietnam Pro" pitchFamily="34" charset="-120"/>
-              </a:rPr>
-              <a:t> đề</a:t>
-            </a:r>
-            <a:r>
-              <a:rPr lang="en-US" sz="2850" dirty="0" spc="-11" kern="0">
-                <a:solidFill>
-                  <a:srgbClr val="14161C"/>
-                </a:solidFill>
-                <a:latin typeface="Be Vietnam Pro" pitchFamily="34" charset="0"/>
-                <a:ea typeface="Be Vietnam Pro" pitchFamily="34" charset="-122"/>
-                <a:cs typeface="Be Vietnam Pro" pitchFamily="34" charset="-120"/>
-              </a:rPr>
-              <a:t> xuất</a:t>
+              <a:t>Kiểm</a:t>
+            </a:r>
+            <a:r>
+              <a:rPr lang="en-US" sz="2850" dirty="0" spc="-26" kern="0">
+                <a:solidFill>
+                  <a:srgbClr val="14161C"/>
+                </a:solidFill>
+                <a:latin typeface="Be Vietnam Pro" pitchFamily="34" charset="0"/>
+                <a:ea typeface="Be Vietnam Pro" pitchFamily="34" charset="-122"/>
+                <a:cs typeface="Be Vietnam Pro" pitchFamily="34" charset="-120"/>
+              </a:rPr>
+              <a:t> tra</a:t>
+            </a:r>
+            <a:r>
+              <a:rPr lang="en-US" sz="2850" dirty="0" spc="-2" kern="0">
+                <a:solidFill>
+                  <a:srgbClr val="14161C"/>
+                </a:solidFill>
+                <a:latin typeface="Be Vietnam Pro" pitchFamily="34" charset="0"/>
+                <a:ea typeface="Be Vietnam Pro" pitchFamily="34" charset="-122"/>
+                <a:cs typeface="Be Vietnam Pro" pitchFamily="34" charset="-120"/>
+              </a:rPr>
+              <a:t> "có</a:t>
+            </a:r>
+            <a:r>
+              <a:rPr lang="en-US" sz="2850" dirty="0" spc="9" kern="0">
+                <a:solidFill>
+                  <a:srgbClr val="14161C"/>
+                </a:solidFill>
+                <a:latin typeface="Be Vietnam Pro" pitchFamily="34" charset="0"/>
+                <a:ea typeface="Be Vietnam Pro" pitchFamily="34" charset="-122"/>
+                <a:cs typeface="Be Vietnam Pro" pitchFamily="34" charset="-120"/>
+              </a:rPr>
+              <a:t> chứa</a:t>
+            </a:r>
+            <a:r>
+              <a:rPr lang="en-US" sz="2850" dirty="0" spc="-3" kern="0">
+                <a:solidFill>
+                  <a:srgbClr val="14161C"/>
+                </a:solidFill>
+                <a:latin typeface="Be Vietnam Pro" pitchFamily="34" charset="0"/>
+                <a:ea typeface="Be Vietnam Pro" pitchFamily="34" charset="-122"/>
+                <a:cs typeface="Be Vietnam Pro" pitchFamily="34" charset="-120"/>
+              </a:rPr>
+              <a:t> không"</a:t>
+            </a:r>
+            <a:r>
+              <a:rPr lang="en-US" sz="2850" dirty="0" spc="-15" kern="0">
+                <a:solidFill>
+                  <a:srgbClr val="14161C"/>
+                </a:solidFill>
+                <a:latin typeface="Be Vietnam Pro" pitchFamily="34" charset="0"/>
+                <a:ea typeface="Be Vietnam Pro" pitchFamily="34" charset="-122"/>
+                <a:cs typeface="Be Vietnam Pro" pitchFamily="34" charset="-120"/>
+              </a:rPr>
+              <a:t> gần</a:t>
+            </a:r>
+            <a:r>
+              <a:rPr lang="en-US" sz="2850" dirty="0" spc="-1" kern="0">
+                <a:solidFill>
+                  <a:srgbClr val="14161C"/>
+                </a:solidFill>
+                <a:latin typeface="Be Vietnam Pro" pitchFamily="34" charset="0"/>
+                <a:ea typeface="Be Vietnam Pro" pitchFamily="34" charset="-122"/>
+                <a:cs typeface="Be Vietnam Pro" pitchFamily="34" charset="-120"/>
+              </a:rPr>
+              <a:t> đúng,</a:t>
             </a:r>
             <a:endParaRPr lang="en-US" sz="2850" dirty="0"/>
           </a:p>
@@ -7840,37 +7862,15 @@
               <a:buNone/>
             </a:pPr>
             <a:r>
-              <a:rPr lang="en-US" sz="2850" dirty="0" spc="-4" kern="0">
-                <a:solidFill>
-                  <a:srgbClr val="14161C"/>
-                </a:solidFill>
-                <a:latin typeface="Be Vietnam Pro" pitchFamily="34" charset="0"/>
-                <a:ea typeface="Be Vietnam Pro" pitchFamily="34" charset="-122"/>
-                <a:cs typeface="Be Vietnam Pro" pitchFamily="34" charset="-120"/>
-              </a:rPr>
-              <a:t>năm</a:t>
-            </a:r>
-            <a:r>
-              <a:rPr lang="en-US" sz="2850" dirty="0" spc="-12" kern="0">
-                <a:solidFill>
-                  <a:srgbClr val="14161C"/>
-                </a:solidFill>
-                <a:latin typeface="Be Vietnam Pro" pitchFamily="34" charset="0"/>
-                <a:ea typeface="Be Vietnam Pro" pitchFamily="34" charset="-122"/>
-                <a:cs typeface="Be Vietnam Pro" pitchFamily="34" charset="-120"/>
-              </a:rPr>
-              <a:t> 1970,</a:t>
-            </a:r>
-            <a:r>
-              <a:rPr lang="en-US" sz="2850" dirty="0" spc="20" kern="0">
-                <a:solidFill>
-                  <a:srgbClr val="14161C"/>
-                </a:solidFill>
-                <a:latin typeface="Be Vietnam Pro" pitchFamily="34" charset="0"/>
-                <a:ea typeface="Be Vietnam Pro" pitchFamily="34" charset="-122"/>
-                <a:cs typeface="Be Vietnam Pro" pitchFamily="34" charset="-120"/>
-              </a:rPr>
-              <a:t> để</a:t>
+              <a:rPr lang="en-US" sz="2850" dirty="0" spc="-10" kern="0">
+                <a:solidFill>
+                  <a:srgbClr val="14161C"/>
+                </a:solidFill>
+                <a:latin typeface="Be Vietnam Pro" pitchFamily="34" charset="0"/>
+                <a:ea typeface="Be Vietnam Pro" pitchFamily="34" charset="-122"/>
+                <a:cs typeface="Be Vietnam Pro" pitchFamily="34" charset="-120"/>
+              </a:rPr>
+              <a:t>tiết</a:t>
             </a:r>
             <a:r>
               <a:rPr lang="en-US" sz="2850" dirty="0" spc="-1" kern="0">
@@ -7881,29 +7881,18 @@
                 <a:ea typeface="Be Vietnam Pro" pitchFamily="34" charset="-122"/>
                 <a:cs typeface="Be Vietnam Pro" pitchFamily="34" charset="-120"/>
               </a:rPr>
-              <a:t> kiểm</a:t>
-            </a:r>
-            <a:r>
-              <a:rPr lang="en-US" sz="2850" dirty="0" spc="-26" kern="0">
-                <a:solidFill>
-                  <a:srgbClr val="14161C"/>
-                </a:solidFill>
-                <a:latin typeface="Be Vietnam Pro" pitchFamily="34" charset="0"/>
-                <a:ea typeface="Be Vietnam Pro" pitchFamily="34" charset="-122"/>
-                <a:cs typeface="Be Vietnam Pro" pitchFamily="34" charset="-120"/>
-              </a:rPr>
-              <a:t> tra</a:t>
-            </a:r>
-            <a:r>
-              <a:rPr lang="en-US" sz="2850" dirty="0" spc="-10" kern="0">
-                <a:solidFill>
-                  <a:srgbClr val="14161C"/>
-                </a:solidFill>
-                <a:latin typeface="Be Vietnam Pro" pitchFamily="34" charset="0"/>
-                <a:ea typeface="Be Vietnam Pro" pitchFamily="34" charset="-122"/>
-                <a:cs typeface="Be Vietnam Pro" pitchFamily="34" charset="-120"/>
-              </a:rPr>
-              <a:t> một</a:t>
+              <a:t> kiệm</a:t>
+            </a:r>
+            <a:r>
+              <a:rPr lang="en-US" sz="2850" dirty="0" spc="-5" kern="0">
+                <a:solidFill>
+                  <a:srgbClr val="14161C"/>
+                </a:solidFill>
+                <a:latin typeface="Be Vietnam Pro" pitchFamily="34" charset="0"/>
+                <a:ea typeface="Be Vietnam Pro" pitchFamily="34" charset="-122"/>
+                <a:cs typeface="Be Vietnam Pro" pitchFamily="34" charset="-120"/>
+              </a:rPr>
+              <a:t> bộ</a:t>
             </a:r>
             <a:r>
               <a:rPr lang="en-US" sz="2850" dirty="0" spc="-1" kern="0">
@@ -7914,7 +7903,7 @@
                 <a:ea typeface="Be Vietnam Pro" pitchFamily="34" charset="-122"/>
                 <a:cs typeface="Be Vietnam Pro" pitchFamily="34" charset="-120"/>
               </a:rPr>
-              <a:t> phần tử</a:t>
+              <a:t> nhớ,</a:t>
             </a:r>
             <a:endParaRPr lang="en-US" sz="2850" dirty="0"/>
           </a:p>
@@ -7926,26 +7915,26 @@
               <a:buNone/>
             </a:pPr>
             <a:r>
-              <a:rPr lang="en-US" sz="2850" dirty="0" spc="-4" kern="0">
-                <a:solidFill>
-                  <a:srgbClr val="14161C"/>
-                </a:solidFill>
-                <a:latin typeface="Be Vietnam Pro" pitchFamily="34" charset="0"/>
-                <a:ea typeface="Be Vietnam Pro" pitchFamily="34" charset="-122"/>
-                <a:cs typeface="Be Vietnam Pro" pitchFamily="34" charset="-120"/>
-              </a:rPr>
-              <a:t>có</a:t>
-            </a:r>
-            <a:r>
-              <a:rPr lang="en-US" sz="2850" dirty="0" spc="-3" kern="0">
-                <a:solidFill>
-                  <a:srgbClr val="14161C"/>
-                </a:solidFill>
-                <a:latin typeface="Be Vietnam Pro" pitchFamily="34" charset="0"/>
-                <a:ea typeface="Be Vietnam Pro" pitchFamily="34" charset="-122"/>
-                <a:cs typeface="Be Vietnam Pro" pitchFamily="34" charset="-120"/>
-              </a:rPr>
-              <a:t> thuộc</a:t>
+              <a:rPr lang="en-US" sz="2850" dirty="0" spc="-8" kern="0">
+                <a:solidFill>
+                  <a:srgbClr val="14161C"/>
+                </a:solidFill>
+                <a:latin typeface="Be Vietnam Pro" pitchFamily="34" charset="0"/>
+                <a:ea typeface="Be Vietnam Pro" pitchFamily="34" charset="-122"/>
+                <a:cs typeface="Be Vietnam Pro" pitchFamily="34" charset="-120"/>
+              </a:rPr>
+              <a:t>sai</a:t>
+            </a:r>
+            <a:r>
+              <a:rPr lang="en-US" sz="2850" dirty="0" spc="-16" kern="0">
+                <a:solidFill>
+                  <a:srgbClr val="14161C"/>
+                </a:solidFill>
+                <a:latin typeface="Be Vietnam Pro" pitchFamily="34" charset="0"/>
+                <a:ea typeface="Be Vietnam Pro" pitchFamily="34" charset="-122"/>
+                <a:cs typeface="Be Vietnam Pro" pitchFamily="34" charset="-120"/>
+              </a:rPr>
+              <a:t> về</a:t>
             </a:r>
             <a:r>
               <a:rPr lang="en-US" sz="2850" dirty="0" spc="-10" kern="0">
@@ -7959,48 +7948,15 @@
               <a:t> một</a:t>
             </a:r>
             <a:r>
-              <a:rPr lang="en-US" sz="2850" dirty="0" spc="-16" kern="0">
-                <a:solidFill>
-                  <a:srgbClr val="14161C"/>
-                </a:solidFill>
-                <a:latin typeface="Be Vietnam Pro" pitchFamily="34" charset="0"/>
-                <a:ea typeface="Be Vietnam Pro" pitchFamily="34" charset="-122"/>
-                <a:cs typeface="Be Vietnam Pro" pitchFamily="34" charset="-120"/>
-              </a:rPr>
-              <a:t> tập</a:t>
-            </a:r>
-            <a:r>
-              <a:rPr lang="en-US" sz="2850" dirty="0" spc="-1" kern="0">
-                <a:solidFill>
-                  <a:srgbClr val="14161C"/>
-                </a:solidFill>
-                <a:latin typeface="Be Vietnam Pro" pitchFamily="34" charset="0"/>
-                <a:ea typeface="Be Vietnam Pro" pitchFamily="34" charset="-122"/>
-                <a:cs typeface="Be Vietnam Pro" pitchFamily="34" charset="-120"/>
-              </a:rPr>
-              <a:t> hợp</a:t>
-            </a:r>
-            <a:r>
-              <a:rPr lang="en-US" sz="2850" dirty="0" spc="-8" kern="0">
-                <a:solidFill>
-                  <a:srgbClr val="14161C"/>
-                </a:solidFill>
-                <a:latin typeface="Be Vietnam Pro" pitchFamily="34" charset="0"/>
-                <a:ea typeface="Be Vietnam Pro" pitchFamily="34" charset="-122"/>
-                <a:cs typeface="Be Vietnam Pro" pitchFamily="34" charset="-120"/>
-              </a:rPr>
-              <a:t> hay</a:t>
-            </a:r>
-            <a:r>
-              <a:rPr lang="en-US" sz="2850" dirty="0" spc="-2" kern="0">
-                <a:solidFill>
-                  <a:srgbClr val="14161C"/>
-                </a:solidFill>
-                <a:latin typeface="Be Vietnam Pro" pitchFamily="34" charset="0"/>
-                <a:ea typeface="Be Vietnam Pro" pitchFamily="34" charset="-122"/>
-                <a:cs typeface="Be Vietnam Pro" pitchFamily="34" charset="-120"/>
-              </a:rPr>
-              <a:t> không.</a:t>
+              <a:rPr lang="en-US" sz="2850" dirty="0" spc="1" kern="0">
+                <a:solidFill>
+                  <a:srgbClr val="14161C"/>
+                </a:solidFill>
+                <a:latin typeface="Be Vietnam Pro" pitchFamily="34" charset="0"/>
+                <a:ea typeface="Be Vietnam Pro" pitchFamily="34" charset="-122"/>
+                <a:cs typeface="Be Vietnam Pro" pitchFamily="34" charset="-120"/>
+              </a:rPr>
+              <a:t> phía.</a:t>
             </a:r>
             <a:endParaRPr lang="en-US" sz="2850" dirty="0"/>
           </a:p>
@@ -9877,15 +9833,59 @@
               <a:buNone/>
             </a:pPr>
             <a:r>
-              <a:rPr lang="en-US" sz="2850" dirty="0" spc="16" kern="0">
-                <a:solidFill>
-                  <a:srgbClr val="F3EEE3"/>
-                </a:solidFill>
-                <a:latin typeface="Be Vietnam Pro" pitchFamily="34" charset="0"/>
-                <a:ea typeface="Be Vietnam Pro" pitchFamily="34" charset="-122"/>
-                <a:cs typeface="Be Vietnam Pro" pitchFamily="34" charset="-120"/>
-              </a:rPr>
-              <a:t>Đưa</a:t>
+              <a:rPr lang="en-US" sz="2850" dirty="0" spc="-1" kern="0">
+                <a:solidFill>
+                  <a:srgbClr val="F3EEE3"/>
+                </a:solidFill>
+                <a:latin typeface="Be Vietnam Pro" pitchFamily="34" charset="0"/>
+                <a:ea typeface="Be Vietnam Pro" pitchFamily="34" charset="-122"/>
+                <a:cs typeface="Be Vietnam Pro" pitchFamily="34" charset="-120"/>
+              </a:rPr>
+              <a:t>Tính</a:t>
+            </a:r>
+            <a:r>
+              <a:rPr lang="en-US" sz="2850" dirty="0" spc="-3" kern="0">
+                <a:solidFill>
+                  <a:srgbClr val="F3EEE3"/>
+                </a:solidFill>
+                <a:latin typeface="Be Vietnam Pro" pitchFamily="34" charset="0"/>
+                <a:ea typeface="Be Vietnam Pro" pitchFamily="34" charset="-122"/>
+                <a:cs typeface="Be Vietnam Pro" pitchFamily="34" charset="-120"/>
+              </a:rPr>
+              <a:t> ba</a:t>
+            </a:r>
+            <a:r>
+              <a:rPr lang="en-US" sz="2850" dirty="0" spc="3" kern="0">
+                <a:solidFill>
+                  <a:srgbClr val="F3EEE3"/>
+                </a:solidFill>
+                <a:latin typeface="Be Vietnam Pro" pitchFamily="34" charset="0"/>
+                <a:ea typeface="Be Vietnam Pro" pitchFamily="34" charset="-122"/>
+                <a:cs typeface="Be Vietnam Pro" pitchFamily="34" charset="-120"/>
+              </a:rPr>
+              <a:t> vị</a:t>
+            </a:r>
+            <a:r>
+              <a:rPr lang="en-US" sz="2850" dirty="0" spc="15" kern="0">
+                <a:solidFill>
+                  <a:srgbClr val="F3EEE3"/>
+                </a:solidFill>
+                <a:latin typeface="Be Vietnam Pro" pitchFamily="34" charset="0"/>
+                <a:ea typeface="Be Vietnam Pro" pitchFamily="34" charset="-122"/>
+                <a:cs typeface="Be Vietnam Pro" pitchFamily="34" charset="-120"/>
+              </a:rPr>
+              <a:t> trí</a:t>
+            </a:r>
+            <a:r>
+              <a:rPr lang="en-US" sz="2850" dirty="0" spc="0" kern="0">
+                <a:solidFill>
+                  <a:srgbClr val="F3EEE3"/>
+                </a:solidFill>
+                <a:latin typeface="Be Vietnam Pro" pitchFamily="34" charset="0"/>
+                <a:ea typeface="Be Vietnam Pro" pitchFamily="34" charset="-122"/>
+                <a:cs typeface="Be Vietnam Pro" pitchFamily="34" charset="-120"/>
+              </a:rPr>
+              <a:t> từ</a:t>
             </a:r>
             <a:r>
               <a:rPr lang="en-US" sz="2850" dirty="0" spc="30" kern="0">
@@ -9907,62 +9907,7 @@
                 <a:ea typeface="Be Vietnam Pro" pitchFamily="34" charset="-122"/>
                 <a:cs typeface="Be Vietnam Pro" pitchFamily="34" charset="-120"/>
               </a:rPr>
-              <a:t> chỉ qua</a:t>
-            </a:r>
-            <a:r>
-              <a:rPr lang="en-US" sz="2850" dirty="0" spc="-2" kern="0">
-                <a:solidFill>
-                  <a:srgbClr val="F3EEE3"/>
-                </a:solidFill>
-                <a:latin typeface="Be Vietnam Pro" pitchFamily="34" charset="0"/>
-                <a:ea typeface="Be Vietnam Pro" pitchFamily="34" charset="-122"/>
-                <a:cs typeface="Be Vietnam Pro" pitchFamily="34" charset="-120"/>
-              </a:rPr>
-              <a:t> ba</a:t>
-            </a:r>
-            <a:r>
-              <a:rPr lang="en-US" sz="2850" dirty="0" spc="-1" kern="0">
-                <a:solidFill>
-                  <a:srgbClr val="F3EEE3"/>
-                </a:solidFill>
-                <a:latin typeface="Be Vietnam Pro" pitchFamily="34" charset="0"/>
-                <a:ea typeface="Be Vietnam Pro" pitchFamily="34" charset="-122"/>
-                <a:cs typeface="Be Vietnam Pro" pitchFamily="34" charset="-120"/>
-              </a:rPr>
-              <a:t> hàm</a:t>
-            </a:r>
-            <a:r>
-              <a:rPr lang="en-US" sz="2850" dirty="0" spc="-5" kern="0">
-                <a:solidFill>
-                  <a:srgbClr val="F3EEE3"/>
-                </a:solidFill>
-                <a:latin typeface="Be Vietnam Pro" pitchFamily="34" charset="0"/>
-                <a:ea typeface="Be Vietnam Pro" pitchFamily="34" charset="-122"/>
-                <a:cs typeface="Be Vietnam Pro" pitchFamily="34" charset="-120"/>
-              </a:rPr>
-              <a:t> băm</a:t>
-            </a:r>
-            <a:r>
-              <a:rPr lang="en-US" sz="2850" dirty="0" spc="2" kern="0">
-                <a:solidFill>
-                  <a:srgbClr val="F3EEE3"/>
-                </a:solidFill>
-                <a:latin typeface="Be Vietnam Pro" pitchFamily="34" charset="0"/>
-                <a:ea typeface="Be Vietnam Pro" pitchFamily="34" charset="-122"/>
-                <a:cs typeface="Be Vietnam Pro" pitchFamily="34" charset="-120"/>
-              </a:rPr>
-              <a:t> A,</a:t>
-            </a:r>
-            <a:r>
-              <a:rPr lang="en-US" sz="2850" dirty="0" spc="1" kern="0">
-                <a:solidFill>
-                  <a:srgbClr val="F3EEE3"/>
-                </a:solidFill>
-                <a:latin typeface="Be Vietnam Pro" pitchFamily="34" charset="0"/>
-                <a:ea typeface="Be Vietnam Pro" pitchFamily="34" charset="-122"/>
-                <a:cs typeface="Be Vietnam Pro" pitchFamily="34" charset="-120"/>
-              </a:rPr>
-              <a:t> B, C,</a:t>
+              <a:t> chỉ,</a:t>
             </a:r>
             <a:endParaRPr lang="en-US" sz="2850" dirty="0"/>
           </a:p>
@@ -10029,18 +9974,18 @@
               <a:t> tại</a:t>
             </a:r>
             <a:r>
-              <a:rPr lang="en-US" sz="2850" dirty="0" spc="-3" kern="0">
-                <a:solidFill>
-                  <a:srgbClr val="F3EEE3"/>
-                </a:solidFill>
-                <a:latin typeface="Be Vietnam Pro" pitchFamily="34" charset="0"/>
-                <a:ea typeface="Be Vietnam Pro" pitchFamily="34" charset="-122"/>
-                <a:cs typeface="Be Vietnam Pro" pitchFamily="34" charset="-120"/>
-              </a:rPr>
-              <a:t> ba</a:t>
-            </a:r>
-            <a:r>
-              <a:rPr lang="en-US" sz="2850" dirty="0" spc="3" kern="0">
+              <a:rPr lang="en-US" sz="2850" dirty="0" spc="-1" kern="0">
+                <a:solidFill>
+                  <a:srgbClr val="F3EEE3"/>
+                </a:solidFill>
+                <a:latin typeface="Be Vietnam Pro" pitchFamily="34" charset="0"/>
+                <a:ea typeface="Be Vietnam Pro" pitchFamily="34" charset="-122"/>
+                <a:cs typeface="Be Vietnam Pro" pitchFamily="34" charset="-120"/>
+              </a:rPr>
+              <a:t> mỗi</a:t>
+            </a:r>
+            <a:r>
+              <a:rPr lang="en-US" sz="2850" dirty="0" spc="4" kern="0">
                 <a:solidFill>
                   <a:srgbClr val="F3EEE3"/>
                 </a:solidFill>
@@ -10051,37 +9996,15 @@
               <a:t> vị</a:t>
             </a:r>
             <a:r>
-              <a:rPr lang="en-US" sz="2850" dirty="0" spc="15" kern="0">
-                <a:solidFill>
-                  <a:srgbClr val="F3EEE3"/>
-                </a:solidFill>
-                <a:latin typeface="Be Vietnam Pro" pitchFamily="34" charset="0"/>
-                <a:ea typeface="Be Vietnam Pro" pitchFamily="34" charset="-122"/>
-                <a:cs typeface="Be Vietnam Pro" pitchFamily="34" charset="-120"/>
-              </a:rPr>
-              <a:t> trí</a:t>
-            </a:r>
-            <a:r>
-              <a:rPr lang="en-US" sz="2850" dirty="0" spc="-41" kern="0">
-                <a:solidFill>
-                  <a:srgbClr val="F3EEE3"/>
-                </a:solidFill>
-                <a:latin typeface="Be Vietnam Pro" pitchFamily="34" charset="0"/>
-                <a:ea typeface="Be Vietnam Pro" pitchFamily="34" charset="-122"/>
-                <a:cs typeface="Be Vietnam Pro" pitchFamily="34" charset="-120"/>
-              </a:rPr>
-              <a:t> kết</a:t>
-            </a:r>
-            <a:r>
-              <a:rPr lang="en-US" sz="2850" dirty="0" spc="1" kern="0">
-                <a:solidFill>
-                  <a:srgbClr val="F3EEE3"/>
-                </a:solidFill>
-                <a:latin typeface="Be Vietnam Pro" pitchFamily="34" charset="0"/>
-                <a:ea typeface="Be Vietnam Pro" pitchFamily="34" charset="-122"/>
-                <a:cs typeface="Be Vietnam Pro" pitchFamily="34" charset="-120"/>
-              </a:rPr>
-              <a:t> quả.</a:t>
+              <a:rPr lang="en-US" sz="2850" dirty="0" spc="12" kern="0">
+                <a:solidFill>
+                  <a:srgbClr val="F3EEE3"/>
+                </a:solidFill>
+                <a:latin typeface="Be Vietnam Pro" pitchFamily="34" charset="0"/>
+                <a:ea typeface="Be Vietnam Pro" pitchFamily="34" charset="-122"/>
+                <a:cs typeface="Be Vietnam Pro" pitchFamily="34" charset="-120"/>
+              </a:rPr>
+              <a:t> trí.</a:t>
             </a:r>
             <a:endParaRPr lang="en-US" sz="2850" dirty="0"/>
           </a:p>
@@ -12134,6 +12057,17 @@
               <a:buNone/>
             </a:pPr>
             <a:r>
+              <a:rPr lang="en-US" sz="1950" dirty="0" spc="-7" kern="0">
+                <a:solidFill>
+                  <a:srgbClr val="C4C8D6"/>
+                </a:solidFill>
+                <a:latin typeface="Be Vietnam Pro" pitchFamily="34" charset="0"/>
+                <a:ea typeface="Be Vietnam Pro" pitchFamily="34" charset="-122"/>
+                <a:cs typeface="Be Vietnam Pro" pitchFamily="34" charset="-120"/>
+              </a:rPr>
+              <a:t>một</a:t>
+            </a:r>
+            <a:r>
               <a:rPr lang="en-US" sz="1950" dirty="0" spc="-2" kern="0">
                 <a:solidFill>
                   <a:srgbClr val="C4C8D6"/>
@@ -12142,10 +12076,10 @@
                 <a:ea typeface="Be Vietnam Pro" pitchFamily="34" charset="-122"/>
                 <a:cs typeface="Be Vietnam Pro" pitchFamily="34" charset="-120"/>
               </a:rPr>
-              <a:t>chỉ</a:t>
-            </a:r>
-            <a:r>
-              <a:rPr lang="en-US" sz="1950" dirty="0" spc="-7" kern="0">
+              <a:t> bit</a:t>
+            </a:r>
+            <a:r>
+              <a:rPr lang="en-US" sz="1950" dirty="0" spc="-1" kern="0">
                 <a:solidFill>
                   <a:srgbClr val="C4C8D6"/>
                 </a:solidFill>
@@ -12153,7 +12087,29 @@
                 <a:ea typeface="Be Vietnam Pro" pitchFamily="34" charset="-122"/>
                 <a:cs typeface="Be Vietnam Pro" pitchFamily="34" charset="-120"/>
               </a:rPr>
-              <a:t> số</a:t>
+              <a:t> do</a:t>
+            </a:r>
+            <a:r>
+              <a:rPr lang="en-US" sz="1950" dirty="0" spc="1" kern="0">
+                <a:solidFill>
+                  <a:srgbClr val="C4C8D6"/>
+                </a:solidFill>
+                <a:latin typeface="Be Vietnam Pro" pitchFamily="34" charset="0"/>
+                <a:ea typeface="Be Vietnam Pro" pitchFamily="34" charset="-122"/>
+                <a:cs typeface="Be Vietnam Pro" pitchFamily="34" charset="-120"/>
+              </a:rPr>
+              <a:t> hai</a:t>
+            </a:r>
+            <a:r>
+              <a:rPr lang="en-US" sz="1950" dirty="0" spc="20" kern="0">
+                <a:solidFill>
+                  <a:srgbClr val="C4C8D6"/>
+                </a:solidFill>
+                <a:latin typeface="Be Vietnam Pro" pitchFamily="34" charset="0"/>
+                <a:ea typeface="Be Vietnam Pro" pitchFamily="34" charset="-122"/>
+                <a:cs typeface="Be Vietnam Pro" pitchFamily="34" charset="-120"/>
+              </a:rPr>
+              <a:t> địa</a:t>
             </a:r>
             <a:r>
               <a:rPr lang="en-US" sz="1950" dirty="0" spc="-1" kern="0">
@@ -12164,62 +12120,7 @@
                 <a:ea typeface="Be Vietnam Pro" pitchFamily="34" charset="-122"/>
                 <a:cs typeface="Be Vietnam Pro" pitchFamily="34" charset="-120"/>
               </a:rPr>
-              <a:t> 5</a:t>
-            </a:r>
-            <a:r>
-              <a:rPr lang="en-US" sz="1950" dirty="0" spc="-11" kern="0">
-                <a:solidFill>
-                  <a:srgbClr val="C4C8D6"/>
-                </a:solidFill>
-                <a:latin typeface="Be Vietnam Pro" pitchFamily="34" charset="0"/>
-                <a:ea typeface="Be Vietnam Pro" pitchFamily="34" charset="-122"/>
-                <a:cs typeface="Be Vietnam Pro" pitchFamily="34" charset="-120"/>
-              </a:rPr>
-              <a:t> trong</a:t>
-            </a:r>
-            <a:r>
-              <a:rPr lang="en-US" sz="1950" dirty="0" spc="-2" kern="0">
-                <a:solidFill>
-                  <a:srgbClr val="C4C8D6"/>
-                </a:solidFill>
-                <a:latin typeface="Be Vietnam Pro" pitchFamily="34" charset="0"/>
-                <a:ea typeface="Be Vietnam Pro" pitchFamily="34" charset="-122"/>
-                <a:cs typeface="Be Vietnam Pro" pitchFamily="34" charset="-120"/>
-              </a:rPr>
-              <a:t> ví</a:t>
-            </a:r>
-            <a:r>
-              <a:rPr lang="en-US" sz="1950" dirty="0" spc="-1" kern="0">
-                <a:solidFill>
-                  <a:srgbClr val="C4C8D6"/>
-                </a:solidFill>
-                <a:latin typeface="Be Vietnam Pro" pitchFamily="34" charset="0"/>
-                <a:ea typeface="Be Vietnam Pro" pitchFamily="34" charset="-122"/>
-                <a:cs typeface="Be Vietnam Pro" pitchFamily="34" charset="-120"/>
-              </a:rPr>
-              <a:t> dụ</a:t>
-            </a:r>
-            <a:r>
-              <a:rPr lang="en-US" sz="1950" dirty="0" spc="0" kern="0">
-                <a:solidFill>
-                  <a:srgbClr val="C4C8D6"/>
-                </a:solidFill>
-                <a:latin typeface="Be Vietnam Pro" pitchFamily="34" charset="0"/>
-                <a:ea typeface="Be Vietnam Pro" pitchFamily="34" charset="-122"/>
-                <a:cs typeface="Be Vietnam Pro" pitchFamily="34" charset="-120"/>
-              </a:rPr>
-              <a:t> của</a:t>
-            </a:r>
-            <a:r>
-              <a:rPr lang="en-US" sz="1950" dirty="0" spc="2" kern="0">
-                <a:solidFill>
-                  <a:srgbClr val="C4C8D6"/>
-                </a:solidFill>
-                <a:latin typeface="Be Vietnam Pro" pitchFamily="34" charset="0"/>
-                <a:ea typeface="Be Vietnam Pro" pitchFamily="34" charset="-122"/>
-                <a:cs typeface="Be Vietnam Pro" pitchFamily="34" charset="-120"/>
-              </a:rPr>
-              <a:t> nguồn</a:t>
+              <a:t> chỉ đặt</a:t>
             </a:r>
             <a:endParaRPr lang="en-US" sz="1950" dirty="0"/>
           </a:p>
@@ -12337,7 +12238,7 @@
               <a:t> B,</a:t>
             </a:r>
             <a:r>
-              <a:rPr lang="en-US" sz="2250" b="1" dirty="0" spc="6" kern="0">
+              <a:rPr lang="en-US" sz="2250" b="1" dirty="0" spc="5" kern="0">
                 <a:solidFill>
                   <a:srgbClr val="3DD6A0"/>
                 </a:solidFill>
@@ -12345,10 +12246,10 @@
                 <a:ea typeface="Be Vietnam Pro" pitchFamily="34" charset="-122"/>
                 <a:cs typeface="Be Vietnam Pro" pitchFamily="34" charset="-120"/>
               </a:rPr>
-              <a:t> C</a:t>
-            </a:r>
-            <a:r>
-              <a:rPr lang="en-US" sz="2250" b="1" dirty="0" spc="-2" kern="0">
+              <a:t> C:</a:t>
+            </a:r>
+            <a:r>
+              <a:rPr lang="en-US" sz="2250" b="1" dirty="0" spc="1" kern="0">
                 <a:solidFill>
                   <a:srgbClr val="3DD6A0"/>
                 </a:solidFill>
@@ -12356,10 +12257,10 @@
                 <a:ea typeface="Be Vietnam Pro" pitchFamily="34" charset="-122"/>
                 <a:cs typeface="Be Vietnam Pro" pitchFamily="34" charset="-120"/>
               </a:rPr>
-              <a:t> là</a:t>
-            </a:r>
-            <a:r>
-              <a:rPr lang="en-US" sz="2250" b="1" dirty="0" spc="0" kern="0">
+              <a:t> ba</a:t>
+            </a:r>
+            <a:r>
+              <a:rPr lang="en-US" sz="2250" b="1" dirty="0" spc="3" kern="0">
                 <a:solidFill>
                   <a:srgbClr val="3DD6A0"/>
                 </a:solidFill>
@@ -12367,7 +12268,40 @@
                 <a:ea typeface="Be Vietnam Pro" pitchFamily="34" charset="-122"/>
                 <a:cs typeface="Be Vietnam Pro" pitchFamily="34" charset="-120"/>
               </a:rPr>
-              <a:t> ba</a:t>
+              <a:t> vị</a:t>
+            </a:r>
+            <a:r>
+              <a:rPr lang="en-US" sz="2250" b="1" dirty="0" spc="9" kern="0">
+                <a:solidFill>
+                  <a:srgbClr val="3DD6A0"/>
+                </a:solidFill>
+                <a:latin typeface="Be Vietnam Pro" pitchFamily="34" charset="0"/>
+                <a:ea typeface="Be Vietnam Pro" pitchFamily="34" charset="-122"/>
+                <a:cs typeface="Be Vietnam Pro" pitchFamily="34" charset="-120"/>
+              </a:rPr>
+              <a:t> trí,</a:t>
+            </a:r>
+            <a:r>
+              <a:rPr lang="en-US" sz="2250" b="1" dirty="0" spc="4" kern="0">
+                <a:solidFill>
+                  <a:srgbClr val="3DD6A0"/>
+                </a:solidFill>
+                <a:latin typeface="Be Vietnam Pro" pitchFamily="34" charset="0"/>
+                <a:ea typeface="Be Vietnam Pro" pitchFamily="34" charset="-122"/>
+                <a:cs typeface="Be Vietnam Pro" pitchFamily="34" charset="-120"/>
+              </a:rPr>
+              <a:t> chỉ</a:t>
+            </a:r>
+            <a:r>
+              <a:rPr lang="en-US" sz="2250" b="1" dirty="0" spc="9" kern="0">
+                <a:solidFill>
+                  <a:srgbClr val="3DD6A0"/>
+                </a:solidFill>
+                <a:latin typeface="Be Vietnam Pro" pitchFamily="34" charset="0"/>
+                <a:ea typeface="Be Vietnam Pro" pitchFamily="34" charset="-122"/>
+                <a:cs typeface="Be Vietnam Pro" pitchFamily="34" charset="-120"/>
+              </a:rPr>
+              <a:t> để</a:t>
             </a:r>
             <a:r>
               <a:rPr lang="en-US" sz="2250" b="1" dirty="0" spc="3" kern="0">
@@ -12378,10 +12312,10 @@
                 <a:ea typeface="Be Vietnam Pro" pitchFamily="34" charset="-122"/>
                 <a:cs typeface="Be Vietnam Pro" pitchFamily="34" charset="-120"/>
               </a:rPr>
-              <a:t> hàm băm khác</a:t>
-            </a:r>
-            <a:r>
-              <a:rPr lang="en-US" sz="2250" b="1" dirty="0" spc="2" kern="0">
+              <a:t> minh</a:t>
+            </a:r>
+            <a:r>
+              <a:rPr lang="en-US" sz="2250" b="1" dirty="0" spc="-1" kern="0">
                 <a:solidFill>
                   <a:srgbClr val="3DD6A0"/>
                 </a:solidFill>
@@ -12389,7 +12323,7 @@
                 <a:ea typeface="Be Vietnam Pro" pitchFamily="34" charset="-122"/>
                 <a:cs typeface="Be Vietnam Pro" pitchFamily="34" charset="-120"/>
               </a:rPr>
-              <a:t> nhau</a:t>
+              <a:t> họa</a:t>
             </a:r>
             <a:endParaRPr lang="en-US" sz="2250" dirty="0"/>
           </a:p>
@@ -13082,15 +13016,15 @@
               <a:buNone/>
             </a:pPr>
             <a:r>
-              <a:rPr lang="en-US" sz="2850" dirty="0" spc="-3" kern="0">
-                <a:solidFill>
-                  <a:srgbClr val="14161C"/>
-                </a:solidFill>
-                <a:latin typeface="Be Vietnam Pro" pitchFamily="34" charset="0"/>
-                <a:ea typeface="Be Vietnam Pro" pitchFamily="34" charset="-122"/>
-                <a:cs typeface="Be Vietnam Pro" pitchFamily="34" charset="-120"/>
-              </a:rPr>
-              <a:t>Áp</a:t>
+              <a:rPr lang="en-US" sz="2850" dirty="0" spc="-1" kern="0">
+                <a:solidFill>
+                  <a:srgbClr val="14161C"/>
+                </a:solidFill>
+                <a:latin typeface="Be Vietnam Pro" pitchFamily="34" charset="0"/>
+                <a:ea typeface="Be Vietnam Pro" pitchFamily="34" charset="-122"/>
+                <a:cs typeface="Be Vietnam Pro" pitchFamily="34" charset="-120"/>
+              </a:rPr>
+              <a:t>Tính</a:t>
             </a:r>
             <a:r>
               <a:rPr lang="en-US" sz="2850" dirty="0" spc="2" kern="0">
@@ -13104,17 +13038,6 @@
               <a:t> lại</a:t>
             </a:r>
             <a:r>
-              <a:rPr lang="en-US" sz="2850" dirty="0" spc="-2" kern="0">
-                <a:solidFill>
-                  <a:srgbClr val="14161C"/>
-                </a:solidFill>
-                <a:latin typeface="Be Vietnam Pro" pitchFamily="34" charset="0"/>
-                <a:ea typeface="Be Vietnam Pro" pitchFamily="34" charset="-122"/>
-                <a:cs typeface="Be Vietnam Pro" pitchFamily="34" charset="-120"/>
-              </a:rPr>
-              <a:t> đúng ba</a:t>
-            </a:r>
-            <a:r>
               <a:rPr lang="en-US" sz="2850" dirty="0" spc="-1" kern="0">
                 <a:solidFill>
                   <a:srgbClr val="14161C"/>
@@ -13123,7 +13046,7 @@
                 <a:ea typeface="Be Vietnam Pro" pitchFamily="34" charset="-122"/>
                 <a:cs typeface="Be Vietnam Pro" pitchFamily="34" charset="-120"/>
               </a:rPr>
-              <a:t> hàm</a:t>
+              <a:t> đúng</a:t>
             </a:r>
             <a:r>
               <a:rPr lang="en-US" sz="2850" dirty="0" spc="-4" kern="0">
@@ -13134,18 +13057,40 @@
                 <a:ea typeface="Be Vietnam Pro" pitchFamily="34" charset="-122"/>
                 <a:cs typeface="Be Vietnam Pro" pitchFamily="34" charset="-120"/>
               </a:rPr>
-              <a:t> băm</a:t>
-            </a:r>
-            <a:r>
-              <a:rPr lang="en-US" sz="2850" dirty="0" spc="0" kern="0">
-                <a:solidFill>
-                  <a:srgbClr val="14161C"/>
-                </a:solidFill>
-                <a:latin typeface="Be Vietnam Pro" pitchFamily="34" charset="0"/>
-                <a:ea typeface="Be Vietnam Pro" pitchFamily="34" charset="-122"/>
-                <a:cs typeface="Be Vietnam Pro" pitchFamily="34" charset="-120"/>
-              </a:rPr>
-              <a:t> lên</a:t>
+              <a:t> ba</a:t>
+            </a:r>
+            <a:r>
+              <a:rPr lang="en-US" sz="2850" dirty="0" spc="3" kern="0">
+                <a:solidFill>
+                  <a:srgbClr val="14161C"/>
+                </a:solidFill>
+                <a:latin typeface="Be Vietnam Pro" pitchFamily="34" charset="0"/>
+                <a:ea typeface="Be Vietnam Pro" pitchFamily="34" charset="-122"/>
+                <a:cs typeface="Be Vietnam Pro" pitchFamily="34" charset="-120"/>
+              </a:rPr>
+              <a:t> vị</a:t>
+            </a:r>
+            <a:r>
+              <a:rPr lang="en-US" sz="2850" dirty="0" spc="16" kern="0">
+                <a:solidFill>
+                  <a:srgbClr val="14161C"/>
+                </a:solidFill>
+                <a:latin typeface="Be Vietnam Pro" pitchFamily="34" charset="0"/>
+                <a:ea typeface="Be Vietnam Pro" pitchFamily="34" charset="-122"/>
+                <a:cs typeface="Be Vietnam Pro" pitchFamily="34" charset="-120"/>
+              </a:rPr>
+              <a:t> trí</a:t>
+            </a:r>
+            <a:r>
+              <a:rPr lang="en-US" sz="2850" dirty="0" spc="1" kern="0">
+                <a:solidFill>
+                  <a:srgbClr val="14161C"/>
+                </a:solidFill>
+                <a:latin typeface="Be Vietnam Pro" pitchFamily="34" charset="0"/>
+                <a:ea typeface="Be Vietnam Pro" pitchFamily="34" charset="-122"/>
+                <a:cs typeface="Be Vietnam Pro" pitchFamily="34" charset="-120"/>
+              </a:rPr>
+              <a:t> của</a:t>
             </a:r>
             <a:endParaRPr lang="en-US" sz="2850" dirty="0"/>
           </a:p>
@@ -15659,48 +15604,15 @@
               <a:buNone/>
             </a:pPr>
             <a:r>
-              <a:rPr lang="en-US" sz="2850" dirty="0" spc="-3" kern="0">
-                <a:solidFill>
-                  <a:srgbClr val="F3EEE3"/>
-                </a:solidFill>
-                <a:latin typeface="Be Vietnam Pro" pitchFamily="34" charset="0"/>
-                <a:ea typeface="Be Vietnam Pro" pitchFamily="34" charset="-122"/>
-                <a:cs typeface="Be Vietnam Pro" pitchFamily="34" charset="-120"/>
-              </a:rPr>
-              <a:t>Nguồn</a:t>
-            </a:r>
-            <a:r>
-              <a:rPr lang="en-US" sz="2850" dirty="0" spc="1" kern="0">
-                <a:solidFill>
-                  <a:srgbClr val="F3EEE3"/>
-                </a:solidFill>
-                <a:latin typeface="Be Vietnam Pro" pitchFamily="34" charset="0"/>
-                <a:ea typeface="Be Vietnam Pro" pitchFamily="34" charset="-122"/>
-                <a:cs typeface="Be Vietnam Pro" pitchFamily="34" charset="-120"/>
-              </a:rPr>
-              <a:t> nêu:</a:t>
-            </a:r>
-            <a:r>
-              <a:rPr lang="en-US" sz="2850" dirty="0" spc="-16" kern="0">
-                <a:solidFill>
-                  <a:srgbClr val="F3EEE3"/>
-                </a:solidFill>
-                <a:latin typeface="Be Vietnam Pro" pitchFamily="34" charset="0"/>
-                <a:ea typeface="Be Vietnam Pro" pitchFamily="34" charset="-122"/>
-                <a:cs typeface="Be Vietnam Pro" pitchFamily="34" charset="-120"/>
-              </a:rPr>
-              <a:t> RedisBloom</a:t>
-            </a:r>
-            <a:r>
-              <a:rPr lang="en-US" sz="2850" dirty="0" spc="-15" kern="0">
-                <a:solidFill>
-                  <a:srgbClr val="F3EEE3"/>
-                </a:solidFill>
-                <a:latin typeface="Be Vietnam Pro" pitchFamily="34" charset="0"/>
-                <a:ea typeface="Be Vietnam Pro" pitchFamily="34" charset="-122"/>
-                <a:cs typeface="Be Vietnam Pro" pitchFamily="34" charset="-120"/>
-              </a:rPr>
-              <a:t> và</a:t>
+              <a:rPr lang="en-US" sz="2850" dirty="0" spc="-4" kern="0">
+                <a:solidFill>
+                  <a:srgbClr val="F3EEE3"/>
+                </a:solidFill>
+                <a:latin typeface="Be Vietnam Pro" pitchFamily="34" charset="0"/>
+                <a:ea typeface="Be Vietnam Pro" pitchFamily="34" charset="-122"/>
+                <a:cs typeface="Be Vietnam Pro" pitchFamily="34" charset="-120"/>
+              </a:rPr>
+              <a:t>Spark</a:t>
             </a:r>
             <a:r>
               <a:rPr lang="en-US" sz="2850" dirty="0" spc="-2" kern="0">
@@ -15711,7 +15623,29 @@
                 <a:ea typeface="Be Vietnam Pro" pitchFamily="34" charset="-122"/>
                 <a:cs typeface="Be Vietnam Pro" pitchFamily="34" charset="-120"/>
               </a:rPr>
-              <a:t> Spark</a:t>
+              <a:t> dùng</a:t>
+            </a:r>
+            <a:r>
+              <a:rPr lang="en-US" sz="2850" dirty="0" spc="-5" kern="0">
+                <a:solidFill>
+                  <a:srgbClr val="F3EEE3"/>
+                </a:solidFill>
+                <a:latin typeface="Be Vietnam Pro" pitchFamily="34" charset="0"/>
+                <a:ea typeface="Be Vietnam Pro" pitchFamily="34" charset="-122"/>
+                <a:cs typeface="Be Vietnam Pro" pitchFamily="34" charset="-120"/>
+              </a:rPr>
+              <a:t> bộ băm</a:t>
+            </a:r>
+            <a:r>
+              <a:rPr lang="en-US" sz="2850" dirty="0" spc="3" kern="0">
+                <a:solidFill>
+                  <a:srgbClr val="F3EEE3"/>
+                </a:solidFill>
+                <a:latin typeface="Be Vietnam Pro" pitchFamily="34" charset="0"/>
+                <a:ea typeface="Be Vietnam Pro" pitchFamily="34" charset="-122"/>
+                <a:cs typeface="Be Vietnam Pro" pitchFamily="34" charset="-120"/>
+              </a:rPr>
+              <a:t> Murmur3</a:t>
             </a:r>
             <a:endParaRPr lang="en-US" sz="2850" dirty="0"/>
           </a:p>
@@ -15723,15 +15657,59 @@
               <a:buNone/>
             </a:pPr>
             <a:r>
-              <a:rPr lang="en-US" sz="2850" dirty="0" spc="-4" kern="0">
-                <a:solidFill>
-                  <a:srgbClr val="F3EEE3"/>
-                </a:solidFill>
-                <a:latin typeface="Be Vietnam Pro" pitchFamily="34" charset="0"/>
-                <a:ea typeface="Be Vietnam Pro" pitchFamily="34" charset="-122"/>
-                <a:cs typeface="Be Vietnam Pro" pitchFamily="34" charset="-120"/>
-              </a:rPr>
-              <a:t>dùng</a:t>
+              <a:rPr lang="en-US" sz="2850" dirty="0" spc="6" kern="0">
+                <a:solidFill>
+                  <a:srgbClr val="F3EEE3"/>
+                </a:solidFill>
+                <a:latin typeface="Be Vietnam Pro" pitchFamily="34" charset="0"/>
+                <a:ea typeface="Be Vietnam Pro" pitchFamily="34" charset="-122"/>
+                <a:cs typeface="Be Vietnam Pro" pitchFamily="34" charset="-120"/>
+              </a:rPr>
+              <a:t>32</a:t>
+            </a:r>
+            <a:r>
+              <a:rPr lang="en-US" sz="2850" dirty="0" spc="0" kern="0">
+                <a:solidFill>
+                  <a:srgbClr val="F3EEE3"/>
+                </a:solidFill>
+                <a:latin typeface="Be Vietnam Pro" pitchFamily="34" charset="0"/>
+                <a:ea typeface="Be Vietnam Pro" pitchFamily="34" charset="-122"/>
+                <a:cs typeface="Be Vietnam Pro" pitchFamily="34" charset="-120"/>
+              </a:rPr>
+              <a:t> bit,</a:t>
+            </a:r>
+            <a:r>
+              <a:rPr lang="en-US" sz="2850" dirty="0" spc="-3" kern="0">
+                <a:solidFill>
+                  <a:srgbClr val="F3EEE3"/>
+                </a:solidFill>
+                <a:latin typeface="Be Vietnam Pro" pitchFamily="34" charset="0"/>
+                <a:ea typeface="Be Vietnam Pro" pitchFamily="34" charset="-122"/>
+                <a:cs typeface="Be Vietnam Pro" pitchFamily="34" charset="-120"/>
+              </a:rPr>
+              <a:t> theo</a:t>
+            </a:r>
+            <a:r>
+              <a:rPr lang="en-US" sz="2850" dirty="0" spc="-1" kern="0">
+                <a:solidFill>
+                  <a:srgbClr val="F3EEE3"/>
+                </a:solidFill>
+                <a:latin typeface="Be Vietnam Pro" pitchFamily="34" charset="0"/>
+                <a:ea typeface="Be Vietnam Pro" pitchFamily="34" charset="-122"/>
+                <a:cs typeface="Be Vietnam Pro" pitchFamily="34" charset="-120"/>
+              </a:rPr>
+              <a:t> mã</a:t>
+            </a:r>
+            <a:r>
+              <a:rPr lang="en-US" sz="2850" dirty="0" spc="-2" kern="0">
+                <a:solidFill>
+                  <a:srgbClr val="F3EEE3"/>
+                </a:solidFill>
+                <a:latin typeface="Be Vietnam Pro" pitchFamily="34" charset="0"/>
+                <a:ea typeface="Be Vietnam Pro" pitchFamily="34" charset="-122"/>
+                <a:cs typeface="Be Vietnam Pro" pitchFamily="34" charset="-120"/>
+              </a:rPr>
+              <a:t> nguồn</a:t>
             </a:r>
             <a:r>
               <a:rPr lang="en-US" sz="2850" dirty="0" spc="1" kern="0">
@@ -15742,7 +15720,7 @@
                 <a:ea typeface="Be Vietnam Pro" pitchFamily="34" charset="-122"/>
                 <a:cs typeface="Be Vietnam Pro" pitchFamily="34" charset="-120"/>
               </a:rPr>
-              <a:t> murmur,</a:t>
+              <a:t> của</a:t>
             </a:r>
             <a:r>
               <a:rPr lang="en-US" sz="2850" dirty="0" spc="0" kern="0">
@@ -15753,29 +15731,7 @@
                 <a:ea typeface="Be Vietnam Pro" pitchFamily="34" charset="-122"/>
                 <a:cs typeface="Be Vietnam Pro" pitchFamily="34" charset="-120"/>
               </a:rPr>
-              <a:t> InfluxDB</a:t>
-            </a:r>
-            <a:r>
-              <a:rPr lang="en-US" sz="2850" dirty="0" spc="-2" kern="0">
-                <a:solidFill>
-                  <a:srgbClr val="F3EEE3"/>
-                </a:solidFill>
-                <a:latin typeface="Be Vietnam Pro" pitchFamily="34" charset="0"/>
-                <a:ea typeface="Be Vietnam Pro" pitchFamily="34" charset="-122"/>
-                <a:cs typeface="Be Vietnam Pro" pitchFamily="34" charset="-120"/>
-              </a:rPr>
-              <a:t> dùng</a:t>
-            </a:r>
-            <a:r>
-              <a:rPr lang="en-US" sz="2850" dirty="0" spc="2" kern="0">
-                <a:solidFill>
-                  <a:srgbClr val="F3EEE3"/>
-                </a:solidFill>
-                <a:latin typeface="Be Vietnam Pro" pitchFamily="34" charset="0"/>
-                <a:ea typeface="Be Vietnam Pro" pitchFamily="34" charset="-122"/>
-                <a:cs typeface="Be Vietnam Pro" pitchFamily="34" charset="-120"/>
-              </a:rPr>
-              <a:t> xxhash.</a:t>
+              <a:t> nó.</a:t>
             </a:r>
             <a:endParaRPr lang="en-US" sz="2850" dirty="0"/>
           </a:p>
@@ -16689,15 +16645,15 @@
               <a:buNone/>
             </a:pPr>
             <a:r>
-              <a:rPr lang="en-US" sz="3150" b="1" dirty="0" spc="-9" kern="0">
-                <a:solidFill>
-                  <a:srgbClr val="F3EEE3"/>
-                </a:solidFill>
-                <a:latin typeface="Be Vietnam Pro" pitchFamily="34" charset="0"/>
-                <a:ea typeface="Be Vietnam Pro" pitchFamily="34" charset="-122"/>
-                <a:cs typeface="Be Vietnam Pro" pitchFamily="34" charset="-120"/>
-              </a:rPr>
-              <a:t>Nguồn</a:t>
+              <a:rPr lang="en-US" sz="3150" b="1" dirty="0" spc="0" kern="0">
+                <a:solidFill>
+                  <a:srgbClr val="F3EEE3"/>
+                </a:solidFill>
+                <a:latin typeface="Be Vietnam Pro" pitchFamily="34" charset="0"/>
+                <a:ea typeface="Be Vietnam Pro" pitchFamily="34" charset="-122"/>
+                <a:cs typeface="Be Vietnam Pro" pitchFamily="34" charset="-120"/>
+              </a:rPr>
+              <a:t>Bài</a:t>
             </a:r>
             <a:r>
               <a:rPr lang="en-US" sz="3150" b="1" dirty="0" spc="-10" kern="0">
@@ -20579,7 +20535,7 @@
               <a:buNone/>
             </a:pPr>
             <a:r>
-              <a:rPr lang="en-US" sz="7200" dirty="0" spc="-1" kern="0">
+              <a:rPr lang="en-US" sz="4200" dirty="0" spc="-49" kern="0">
                 <a:solidFill>
                   <a:srgbClr val="C4C8D6"/>
                 </a:solidFill>
@@ -20587,9 +20543,31 @@
                 <a:ea typeface="Bricolage Grotesque ExtraBold" pitchFamily="34" charset="-122"/>
                 <a:cs typeface="Bricolage Grotesque ExtraBold" pitchFamily="34" charset="-120"/>
               </a:rPr>
-              <a:t>DB</a:t>
-            </a:r>
-            <a:endParaRPr lang="en-US" sz="7200" dirty="0"/>
+              <a:t>Dương</a:t>
+            </a:r>
+            <a:r>
+              <a:rPr lang="en-US" sz="4200" dirty="0" spc="-2" kern="0">
+                <a:solidFill>
+                  <a:srgbClr val="C4C8D6"/>
+                </a:solidFill>
+                <a:latin typeface="Bricolage Grotesque ExtraBold" pitchFamily="34" charset="0"/>
+                <a:ea typeface="Bricolage Grotesque ExtraBold" pitchFamily="34" charset="-122"/>
+                <a:cs typeface="Bricolage Grotesque ExtraBold" pitchFamily="34" charset="-120"/>
+              </a:rPr>
+              <a:t> tính</a:t>
+            </a:r>
+            <a:r>
+              <a:rPr lang="en-US" sz="4200" dirty="0" spc="2" kern="0">
+                <a:solidFill>
+                  <a:srgbClr val="C4C8D6"/>
+                </a:solidFill>
+                <a:latin typeface="Bricolage Grotesque ExtraBold" pitchFamily="34" charset="0"/>
+                <a:ea typeface="Bricolage Grotesque ExtraBold" pitchFamily="34" charset="-122"/>
+                <a:cs typeface="Bricolage Grotesque ExtraBold" pitchFamily="34" charset="-120"/>
+              </a:rPr>
+              <a:t> giả</a:t>
+            </a:r>
+            <a:endParaRPr lang="en-US" sz="4200" dirty="0"/>
           </a:p>
         </p:txBody>
       </p:sp>
@@ -20618,7 +20596,7 @@
               <a:buNone/>
             </a:pPr>
             <a:r>
-              <a:rPr lang="en-US" sz="2100" dirty="0" spc="-13" kern="0">
+              <a:rPr lang="en-US" sz="2100" dirty="0" spc="-18" kern="0">
                 <a:solidFill>
                   <a:srgbClr val="C4C8D6"/>
                 </a:solidFill>
@@ -20626,7 +20604,18 @@
                 <a:ea typeface="Be Vietnam Pro" pitchFamily="34" charset="-122"/>
                 <a:cs typeface="Be Vietnam Pro" pitchFamily="34" charset="-120"/>
               </a:rPr>
-              <a:t>DataBase</a:t>
+              <a:t>false</a:t>
+            </a:r>
+            <a:r>
+              <a:rPr lang="en-US" sz="2100" dirty="0" spc="-7" kern="0">
+                <a:solidFill>
+                  <a:srgbClr val="C4C8D6"/>
+                </a:solidFill>
+                <a:latin typeface="Be Vietnam Pro" pitchFamily="34" charset="0"/>
+                <a:ea typeface="Be Vietnam Pro" pitchFamily="34" charset="-122"/>
+                <a:cs typeface="Be Vietnam Pro" pitchFamily="34" charset="-120"/>
+              </a:rPr>
+              <a:t> positive</a:t>
             </a:r>
             <a:endParaRPr lang="en-US" sz="2100" dirty="0"/>
           </a:p>
@@ -20660,6 +20649,39 @@
               <a:buNone/>
             </a:pPr>
             <a:r>
+              <a:rPr lang="en-US" sz="2400" dirty="0" spc="4" kern="0">
+                <a:solidFill>
+                  <a:srgbClr val="F3EEE3"/>
+                </a:solidFill>
+                <a:latin typeface="Be Vietnam Pro" pitchFamily="34" charset="0"/>
+                <a:ea typeface="Be Vietnam Pro" pitchFamily="34" charset="-122"/>
+                <a:cs typeface="Be Vietnam Pro" pitchFamily="34" charset="-120"/>
+              </a:rPr>
+              <a:t>Báo</a:t>
+            </a:r>
+            <a:r>
+              <a:rPr lang="en-US" sz="2400" dirty="0" spc="3" kern="0">
+                <a:solidFill>
+                  <a:srgbClr val="F3EEE3"/>
+                </a:solidFill>
+                <a:latin typeface="Be Vietnam Pro" pitchFamily="34" charset="0"/>
+                <a:ea typeface="Be Vietnam Pro" pitchFamily="34" charset="-122"/>
+                <a:cs typeface="Be Vietnam Pro" pitchFamily="34" charset="-120"/>
+              </a:rPr>
+              <a:t> nhầm</a:t>
+            </a:r>
+            <a:r>
+              <a:rPr lang="en-US" sz="2400" dirty="0" spc="1" kern="0">
+                <a:solidFill>
+                  <a:srgbClr val="F3EEE3"/>
+                </a:solidFill>
+                <a:latin typeface="Be Vietnam Pro" pitchFamily="34" charset="0"/>
+                <a:ea typeface="Be Vietnam Pro" pitchFamily="34" charset="-122"/>
+                <a:cs typeface="Be Vietnam Pro" pitchFamily="34" charset="-120"/>
+              </a:rPr>
+              <a:t> là có</a:t>
+            </a:r>
+            <a:r>
               <a:rPr lang="en-US" sz="2400" dirty="0" spc="0" kern="0">
                 <a:solidFill>
                   <a:srgbClr val="F3EEE3"/>
@@ -20668,106 +20690,7 @@
                 <a:ea typeface="Be Vietnam Pro" pitchFamily="34" charset="-122"/>
                 <a:cs typeface="Be Vietnam Pro" pitchFamily="34" charset="-120"/>
               </a:rPr>
-              <a:t>Cơ</a:t>
-            </a:r>
-            <a:r>
-              <a:rPr lang="en-US" sz="2400" dirty="0" spc="-8" kern="0">
-                <a:solidFill>
-                  <a:srgbClr val="F3EEE3"/>
-                </a:solidFill>
-                <a:latin typeface="Be Vietnam Pro" pitchFamily="34" charset="0"/>
-                <a:ea typeface="Be Vietnam Pro" pitchFamily="34" charset="-122"/>
-                <a:cs typeface="Be Vietnam Pro" pitchFamily="34" charset="-120"/>
-              </a:rPr>
-              <a:t> sở</a:t>
-            </a:r>
-            <a:r>
-              <a:rPr lang="en-US" sz="2400" dirty="0" spc="3" kern="0">
-                <a:solidFill>
-                  <a:srgbClr val="F3EEE3"/>
-                </a:solidFill>
-                <a:latin typeface="Be Vietnam Pro" pitchFamily="34" charset="0"/>
-                <a:ea typeface="Be Vietnam Pro" pitchFamily="34" charset="-122"/>
-                <a:cs typeface="Be Vietnam Pro" pitchFamily="34" charset="-120"/>
-              </a:rPr>
-              <a:t> dữ</a:t>
-            </a:r>
-            <a:r>
-              <a:rPr lang="en-US" sz="2400" dirty="0" spc="-1" kern="0">
-                <a:solidFill>
-                  <a:srgbClr val="F3EEE3"/>
-                </a:solidFill>
-                <a:latin typeface="Be Vietnam Pro" pitchFamily="34" charset="0"/>
-                <a:ea typeface="Be Vietnam Pro" pitchFamily="34" charset="-122"/>
-                <a:cs typeface="Be Vietnam Pro" pitchFamily="34" charset="-120"/>
-              </a:rPr>
-              <a:t> liệu:</a:t>
-            </a:r>
-            <a:r>
-              <a:rPr lang="en-US" sz="2400" dirty="0" spc="0" kern="0">
-                <a:solidFill>
-                  <a:srgbClr val="F3EEE3"/>
-                </a:solidFill>
-                <a:latin typeface="Be Vietnam Pro" pitchFamily="34" charset="0"/>
-                <a:ea typeface="Be Vietnam Pro" pitchFamily="34" charset="-122"/>
-                <a:cs typeface="Be Vietnam Pro" pitchFamily="34" charset="-120"/>
-              </a:rPr>
-              <a:t> nơi</a:t>
-            </a:r>
-            <a:r>
-              <a:rPr lang="en-US" sz="2400" dirty="0" spc="16" kern="0">
-                <a:solidFill>
-                  <a:srgbClr val="F3EEE3"/>
-                </a:solidFill>
-                <a:latin typeface="Be Vietnam Pro" pitchFamily="34" charset="0"/>
-                <a:ea typeface="Be Vietnam Pro" pitchFamily="34" charset="-122"/>
-                <a:cs typeface="Be Vietnam Pro" pitchFamily="34" charset="-120"/>
-              </a:rPr>
-              <a:t> lưu</a:t>
-            </a:r>
-            <a:r>
-              <a:rPr lang="en-US" sz="2400" dirty="0" spc="3" kern="0">
-                <a:solidFill>
-                  <a:srgbClr val="F3EEE3"/>
-                </a:solidFill>
-                <a:latin typeface="Be Vietnam Pro" pitchFamily="34" charset="0"/>
-                <a:ea typeface="Be Vietnam Pro" pitchFamily="34" charset="-122"/>
-                <a:cs typeface="Be Vietnam Pro" pitchFamily="34" charset="-120"/>
-              </a:rPr>
-              <a:t> dữ</a:t>
-            </a:r>
-            <a:r>
-              <a:rPr lang="en-US" sz="2400" dirty="0" spc="-1" kern="0">
-                <a:solidFill>
-                  <a:srgbClr val="F3EEE3"/>
-                </a:solidFill>
-                <a:latin typeface="Be Vietnam Pro" pitchFamily="34" charset="0"/>
-                <a:ea typeface="Be Vietnam Pro" pitchFamily="34" charset="-122"/>
-                <a:cs typeface="Be Vietnam Pro" pitchFamily="34" charset="-120"/>
-              </a:rPr>
-              <a:t> liệu</a:t>
-            </a:r>
-            <a:r>
-              <a:rPr lang="en-US" sz="2400" dirty="0" spc="0" kern="0">
-                <a:solidFill>
-                  <a:srgbClr val="F3EEE3"/>
-                </a:solidFill>
-                <a:latin typeface="Be Vietnam Pro" pitchFamily="34" charset="0"/>
-                <a:ea typeface="Be Vietnam Pro" pitchFamily="34" charset="-122"/>
-                <a:cs typeface="Be Vietnam Pro" pitchFamily="34" charset="-120"/>
-              </a:rPr>
-              <a:t> lâu</a:t>
-            </a:r>
-            <a:r>
-              <a:rPr lang="en-US" sz="2400" dirty="0" spc="1" kern="0">
-                <a:solidFill>
-                  <a:srgbClr val="F3EEE3"/>
-                </a:solidFill>
-                <a:latin typeface="Be Vietnam Pro" pitchFamily="34" charset="0"/>
-                <a:ea typeface="Be Vietnam Pro" pitchFamily="34" charset="-122"/>
-                <a:cs typeface="Be Vietnam Pro" pitchFamily="34" charset="-120"/>
-              </a:rPr>
-              <a:t> dài.</a:t>
+              <a:t> cho</a:t>
             </a:r>
             <a:endParaRPr lang="en-US" sz="2400" dirty="0"/>
           </a:p>
@@ -20779,59 +20702,59 @@
               <a:buNone/>
             </a:pPr>
             <a:r>
-              <a:rPr lang="en-US" sz="2400" dirty="0" spc="-1" kern="0">
-                <a:solidFill>
-                  <a:srgbClr val="F3EEE3"/>
-                </a:solidFill>
-                <a:latin typeface="Be Vietnam Pro" pitchFamily="34" charset="0"/>
-                <a:ea typeface="Be Vietnam Pro" pitchFamily="34" charset="-122"/>
-                <a:cs typeface="Be Vietnam Pro" pitchFamily="34" charset="-120"/>
-              </a:rPr>
-              <a:t>Chỉ</a:t>
-            </a:r>
-            <a:r>
-              <a:rPr lang="en-US" sz="2400" dirty="0" spc="0" kern="0">
-                <a:solidFill>
-                  <a:srgbClr val="F3EEE3"/>
-                </a:solidFill>
-                <a:latin typeface="Be Vietnam Pro" pitchFamily="34" charset="0"/>
-                <a:ea typeface="Be Vietnam Pro" pitchFamily="34" charset="-122"/>
-                <a:cs typeface="Be Vietnam Pro" pitchFamily="34" charset="-120"/>
-              </a:rPr>
-              <a:t> có</a:t>
-            </a:r>
-            <a:r>
-              <a:rPr lang="en-US" sz="2400" dirty="0" spc="-13" kern="0">
-                <a:solidFill>
-                  <a:srgbClr val="F3EEE3"/>
-                </a:solidFill>
-                <a:latin typeface="Be Vietnam Pro" pitchFamily="34" charset="0"/>
-                <a:ea typeface="Be Vietnam Pro" pitchFamily="34" charset="-122"/>
-                <a:cs typeface="Be Vietnam Pro" pitchFamily="34" charset="-120"/>
-              </a:rPr>
-              <a:t> trong</a:t>
-            </a:r>
-            <a:r>
-              <a:rPr lang="en-US" sz="2400" dirty="0" spc="-11" kern="0">
-                <a:solidFill>
-                  <a:srgbClr val="F3EEE3"/>
-                </a:solidFill>
-                <a:latin typeface="Be Vietnam Pro" pitchFamily="34" charset="0"/>
-                <a:ea typeface="Be Vietnam Pro" pitchFamily="34" charset="-122"/>
-                <a:cs typeface="Be Vietnam Pro" pitchFamily="34" charset="-120"/>
-              </a:rPr>
-              <a:t> tên</a:t>
-            </a:r>
-            <a:r>
-              <a:rPr lang="en-US" sz="2400" dirty="0" spc="0" kern="0">
-                <a:solidFill>
-                  <a:srgbClr val="F3EEE3"/>
-                </a:solidFill>
-                <a:latin typeface="Be Vietnam Pro" pitchFamily="34" charset="0"/>
-                <a:ea typeface="Be Vietnam Pro" pitchFamily="34" charset="-122"/>
-                <a:cs typeface="Be Vietnam Pro" pitchFamily="34" charset="-120"/>
-              </a:rPr>
-              <a:t> InfluxDB.</a:t>
+              <a:rPr lang="en-US" sz="2400" dirty="0" spc="2" kern="0">
+                <a:solidFill>
+                  <a:srgbClr val="F3EEE3"/>
+                </a:solidFill>
+                <a:latin typeface="Be Vietnam Pro" pitchFamily="34" charset="0"/>
+                <a:ea typeface="Be Vietnam Pro" pitchFamily="34" charset="-122"/>
+                <a:cs typeface="Be Vietnam Pro" pitchFamily="34" charset="-120"/>
+              </a:rPr>
+              <a:t>phần</a:t>
+            </a:r>
+            <a:r>
+              <a:rPr lang="en-US" sz="2400" dirty="0" spc="3" kern="0">
+                <a:solidFill>
+                  <a:srgbClr val="F3EEE3"/>
+                </a:solidFill>
+                <a:latin typeface="Be Vietnam Pro" pitchFamily="34" charset="0"/>
+                <a:ea typeface="Be Vietnam Pro" pitchFamily="34" charset="-122"/>
+                <a:cs typeface="Be Vietnam Pro" pitchFamily="34" charset="-120"/>
+              </a:rPr>
+              <a:t> tử</a:t>
+            </a:r>
+            <a:r>
+              <a:rPr lang="en-US" sz="2400" dirty="0" spc="6" kern="0">
+                <a:solidFill>
+                  <a:srgbClr val="F3EEE3"/>
+                </a:solidFill>
+                <a:latin typeface="Be Vietnam Pro" pitchFamily="34" charset="0"/>
+                <a:ea typeface="Be Vietnam Pro" pitchFamily="34" charset="-122"/>
+                <a:cs typeface="Be Vietnam Pro" pitchFamily="34" charset="-120"/>
+              </a:rPr>
+              <a:t> chưa</a:t>
+            </a:r>
+            <a:r>
+              <a:rPr lang="en-US" sz="2400" dirty="0" spc="23" kern="0">
+                <a:solidFill>
+                  <a:srgbClr val="F3EEE3"/>
+                </a:solidFill>
+                <a:latin typeface="Be Vietnam Pro" pitchFamily="34" charset="0"/>
+                <a:ea typeface="Be Vietnam Pro" pitchFamily="34" charset="-122"/>
+                <a:cs typeface="Be Vietnam Pro" pitchFamily="34" charset="-120"/>
+              </a:rPr>
+              <a:t> từng</a:t>
+            </a:r>
+            <a:r>
+              <a:rPr lang="en-US" sz="2400" dirty="0" spc="1" kern="0">
+                <a:solidFill>
+                  <a:srgbClr val="F3EEE3"/>
+                </a:solidFill>
+                <a:latin typeface="Be Vietnam Pro" pitchFamily="34" charset="0"/>
+                <a:ea typeface="Be Vietnam Pro" pitchFamily="34" charset="-122"/>
+                <a:cs typeface="Be Vietnam Pro" pitchFamily="34" charset="-120"/>
+              </a:rPr>
+              <a:t> thêm.</a:t>
             </a:r>
             <a:endParaRPr lang="en-US" sz="2400" dirty="0"/>
           </a:p>
@@ -20958,15 +20881,37 @@
               <a:t>ByteByteGo:</a:t>
             </a:r>
             <a:r>
-              <a:rPr lang="en-US" sz="2550" dirty="0" spc="-4" kern="0">
-                <a:solidFill>
-                  <a:srgbClr val="F3EEE3"/>
-                </a:solidFill>
-                <a:latin typeface="Be Vietnam Pro" pitchFamily="34" charset="0"/>
-                <a:ea typeface="Be Vietnam Pro" pitchFamily="34" charset="-122"/>
-                <a:cs typeface="Be Vietnam Pro" pitchFamily="34" charset="-120"/>
-              </a:rPr>
-              <a:t> bài</a:t>
+              <a:rPr lang="en-US" sz="2550" dirty="0" spc="1" kern="0">
+                <a:solidFill>
+                  <a:srgbClr val="F3EEE3"/>
+                </a:solidFill>
+                <a:latin typeface="Be Vietnam Pro" pitchFamily="34" charset="0"/>
+                <a:ea typeface="Be Vietnam Pro" pitchFamily="34" charset="-122"/>
+                <a:cs typeface="Be Vietnam Pro" pitchFamily="34" charset="-120"/>
+              </a:rPr>
+              <a:t> câu</a:t>
+            </a:r>
+            <a:r>
+              <a:rPr lang="en-US" sz="2550" dirty="0" spc="-1" kern="0">
+                <a:solidFill>
+                  <a:srgbClr val="F3EEE3"/>
+                </a:solidFill>
+                <a:latin typeface="Be Vietnam Pro" pitchFamily="34" charset="0"/>
+                <a:ea typeface="Be Vietnam Pro" pitchFamily="34" charset="-122"/>
+                <a:cs typeface="Be Vietnam Pro" pitchFamily="34" charset="-120"/>
+              </a:rPr>
+              <a:t> hỏi,</a:t>
+            </a:r>
+            <a:r>
+              <a:rPr lang="en-US" sz="2550" dirty="0" spc="-5" kern="0">
+                <a:solidFill>
+                  <a:srgbClr val="F3EEE3"/>
+                </a:solidFill>
+                <a:latin typeface="Be Vietnam Pro" pitchFamily="34" charset="0"/>
+                <a:ea typeface="Be Vietnam Pro" pitchFamily="34" charset="-122"/>
+                <a:cs typeface="Be Vietnam Pro" pitchFamily="34" charset="-120"/>
+              </a:rPr>
+              <a:t> ba</a:t>
             </a:r>
             <a:r>
               <a:rPr lang="en-US" sz="2550" dirty="0" spc="0" kern="0">
@@ -20977,84 +20922,18 @@
                 <a:ea typeface="Be Vietnam Pro" pitchFamily="34" charset="-122"/>
                 <a:cs typeface="Be Vietnam Pro" pitchFamily="34" charset="-120"/>
               </a:rPr>
-              <a:t> nguồn</a:t>
-            </a:r>
-            <a:r>
-              <a:rPr lang="en-US" sz="2550" dirty="0" spc="-18" kern="0">
-                <a:solidFill>
-                  <a:srgbClr val="F3EEE3"/>
-                </a:solidFill>
-                <a:latin typeface="Be Vietnam Pro" pitchFamily="34" charset="0"/>
-                <a:ea typeface="Be Vietnam Pro" pitchFamily="34" charset="-122"/>
-                <a:cs typeface="Be Vietnam Pro" pitchFamily="34" charset="-120"/>
-              </a:rPr>
-              <a:t> về</a:t>
-            </a:r>
-            <a:r>
-              <a:rPr lang="en-US" sz="2550" dirty="0" spc="-4" kern="0">
-                <a:solidFill>
-                  <a:srgbClr val="F3EEE3"/>
-                </a:solidFill>
-                <a:latin typeface="Be Vietnam Pro" pitchFamily="34" charset="0"/>
-                <a:ea typeface="Be Vietnam Pro" pitchFamily="34" charset="-122"/>
-                <a:cs typeface="Be Vietnam Pro" pitchFamily="34" charset="-120"/>
-              </a:rPr>
-              <a:t> ba</a:t>
-            </a:r>
-            <a:r>
-              <a:rPr lang="en-US" sz="2550" dirty="0" spc="0" kern="0">
-                <a:solidFill>
-                  <a:srgbClr val="F3EEE3"/>
-                </a:solidFill>
-                <a:latin typeface="Be Vietnam Pro" pitchFamily="34" charset="0"/>
-                <a:ea typeface="Be Vietnam Pro" pitchFamily="34" charset="-122"/>
-                <a:cs typeface="Be Vietnam Pro" pitchFamily="34" charset="-120"/>
-              </a:rPr>
-              <a:t> cách</a:t>
-            </a:r>
-            <a:r>
-              <a:rPr lang="en-US" sz="2550" dirty="0" spc="-18" kern="0">
-                <a:solidFill>
-                  <a:srgbClr val="F3EEE3"/>
-                </a:solidFill>
-                <a:latin typeface="Be Vietnam Pro" pitchFamily="34" charset="0"/>
-                <a:ea typeface="Be Vietnam Pro" pitchFamily="34" charset="-122"/>
-                <a:cs typeface="Be Vietnam Pro" pitchFamily="34" charset="-120"/>
-              </a:rPr>
-              <a:t> và</a:t>
-            </a:r>
-            <a:r>
-              <a:rPr lang="en-US" sz="2550" dirty="0" spc="-5" kern="0">
-                <a:solidFill>
-                  <a:srgbClr val="F3EEE3"/>
-                </a:solidFill>
-                <a:latin typeface="Be Vietnam Pro" pitchFamily="34" charset="0"/>
-                <a:ea typeface="Be Vietnam Pro" pitchFamily="34" charset="-122"/>
-                <a:cs typeface="Be Vietnam Pro" pitchFamily="34" charset="-120"/>
-              </a:rPr>
-              <a:t> bộ</a:t>
-            </a:r>
-            <a:r>
-              <a:rPr lang="en-US" sz="2550" dirty="0" spc="-3" kern="0">
-                <a:solidFill>
-                  <a:srgbClr val="F3EEE3"/>
-                </a:solidFill>
-                <a:latin typeface="Be Vietnam Pro" pitchFamily="34" charset="0"/>
-                <a:ea typeface="Be Vietnam Pro" pitchFamily="34" charset="-122"/>
-                <a:cs typeface="Be Vietnam Pro" pitchFamily="34" charset="-120"/>
-              </a:rPr>
-              <a:t> lọc</a:t>
-            </a:r>
-            <a:r>
-              <a:rPr lang="en-US" sz="2550" dirty="0" spc="-1" kern="0">
-                <a:solidFill>
-                  <a:srgbClr val="F3EEE3"/>
-                </a:solidFill>
-                <a:latin typeface="Be Vietnam Pro" pitchFamily="34" charset="0"/>
-                <a:ea typeface="Be Vietnam Pro" pitchFamily="34" charset="-122"/>
-                <a:cs typeface="Be Vietnam Pro" pitchFamily="34" charset="-120"/>
-              </a:rPr>
-              <a:t> Bloom</a:t>
+              <a:t> cách, năm</a:t>
+            </a:r>
+            <a:r>
+              <a:rPr lang="en-US" sz="2550" dirty="0" spc="-17" kern="0">
+                <a:solidFill>
+                  <a:srgbClr val="F3EEE3"/>
+                </a:solidFill>
+                <a:latin typeface="Be Vietnam Pro" pitchFamily="34" charset="0"/>
+                <a:ea typeface="Be Vietnam Pro" pitchFamily="34" charset="-122"/>
+                <a:cs typeface="Be Vietnam Pro" pitchFamily="34" charset="-120"/>
+              </a:rPr>
+              <a:t> 1970</a:t>
             </a:r>
             <a:endParaRPr lang="en-US" sz="2550" dirty="0"/>
           </a:p>
@@ -21090,70 +20969,15 @@
               <a:t> Spark:</a:t>
             </a:r>
             <a:r>
-              <a:rPr lang="en-US" sz="2550" dirty="0" spc="-5" kern="0">
-                <a:solidFill>
-                  <a:srgbClr val="F3EEE3"/>
-                </a:solidFill>
-                <a:latin typeface="Be Vietnam Pro" pitchFamily="34" charset="0"/>
-                <a:ea typeface="Be Vietnam Pro" pitchFamily="34" charset="-122"/>
-                <a:cs typeface="Be Vietnam Pro" pitchFamily="34" charset="-120"/>
-              </a:rPr>
-              <a:t> BloomFilter</a:t>
-            </a:r>
-            <a:r>
-              <a:rPr lang="en-US" sz="2550" dirty="0" spc="-17" kern="0">
-                <a:solidFill>
-                  <a:srgbClr val="F3EEE3"/>
-                </a:solidFill>
-                <a:latin typeface="Be Vietnam Pro" pitchFamily="34" charset="0"/>
-                <a:ea typeface="Be Vietnam Pro" pitchFamily="34" charset="-122"/>
-                <a:cs typeface="Be Vietnam Pro" pitchFamily="34" charset="-120"/>
-              </a:rPr>
-              <a:t> và</a:t>
-            </a:r>
-            <a:r>
-              <a:rPr lang="en-US" sz="2550" dirty="0" spc="-3" kern="0">
-                <a:solidFill>
-                  <a:srgbClr val="F3EEE3"/>
-                </a:solidFill>
-                <a:latin typeface="Be Vietnam Pro" pitchFamily="34" charset="0"/>
-                <a:ea typeface="Be Vietnam Pro" pitchFamily="34" charset="-122"/>
-                <a:cs typeface="Be Vietnam Pro" pitchFamily="34" charset="-120"/>
-              </a:rPr>
-              <a:t> BloomFilterImpl,</a:t>
-            </a:r>
-            <a:r>
-              <a:rPr lang="en-US" sz="2550" dirty="0" spc="9" kern="0">
-                <a:solidFill>
-                  <a:srgbClr val="F3EEE3"/>
-                </a:solidFill>
-                <a:latin typeface="Be Vietnam Pro" pitchFamily="34" charset="0"/>
-                <a:ea typeface="Be Vietnam Pro" pitchFamily="34" charset="-122"/>
-                <a:cs typeface="Be Vietnam Pro" pitchFamily="34" charset="-120"/>
-              </a:rPr>
-              <a:t> đọc</a:t>
-            </a:r>
-            <a:r>
-              <a:rPr lang="en-US" sz="2550" dirty="0" spc="-1" kern="0">
-                <a:solidFill>
-                  <a:srgbClr val="F3EEE3"/>
-                </a:solidFill>
-                <a:latin typeface="Be Vietnam Pro" pitchFamily="34" charset="0"/>
-                <a:ea typeface="Be Vietnam Pro" pitchFamily="34" charset="-122"/>
-                <a:cs typeface="Be Vietnam Pro" pitchFamily="34" charset="-120"/>
-              </a:rPr>
-              <a:t> từ</a:t>
-            </a:r>
-            <a:r>
-              <a:rPr lang="en-US" sz="2550" dirty="0" spc="0" kern="0">
-                <a:solidFill>
-                  <a:srgbClr val="F3EEE3"/>
-                </a:solidFill>
-                <a:latin typeface="Be Vietnam Pro" pitchFamily="34" charset="0"/>
-                <a:ea typeface="Be Vietnam Pro" pitchFamily="34" charset="-122"/>
-                <a:cs typeface="Be Vietnam Pro" pitchFamily="34" charset="-120"/>
-              </a:rPr>
-              <a:t> kho</a:t>
+              <a:rPr lang="en-US" sz="2550" dirty="0" spc="-4" kern="0">
+                <a:solidFill>
+                  <a:srgbClr val="F3EEE3"/>
+                </a:solidFill>
+                <a:latin typeface="Be Vietnam Pro" pitchFamily="34" charset="0"/>
+                <a:ea typeface="Be Vietnam Pro" pitchFamily="34" charset="-122"/>
+                <a:cs typeface="Be Vietnam Pro" pitchFamily="34" charset="-120"/>
+              </a:rPr>
+              <a:t> BloomFilter, BloomFilterImpl,</a:t>
             </a:r>
             <a:r>
               <a:rPr lang="en-US" sz="2550" dirty="0" spc="1" kern="0">
@@ -21164,7 +20988,7 @@
                 <a:ea typeface="Be Vietnam Pro" pitchFamily="34" charset="-122"/>
                 <a:cs typeface="Be Vietnam Pro" pitchFamily="34" charset="-120"/>
               </a:rPr>
-              <a:t> mã</a:t>
+              <a:t> Murmur3_x86_32</a:t>
             </a:r>
             <a:endParaRPr lang="en-US" sz="2550" dirty="0"/>
           </a:p>
@@ -21239,7 +21063,7 @@
               <a:t> ngày</a:t>
             </a:r>
             <a:r>
-              <a:rPr lang="en-US" sz="2100" dirty="0" spc="-1" kern="0">
+              <a:rPr lang="en-US" sz="2100" dirty="0" spc="0" kern="0">
                 <a:solidFill>
                   <a:srgbClr val="C4C8D6"/>
                 </a:solidFill>
@@ -21247,10 +21071,10 @@
                 <a:ea typeface="Be Vietnam Pro" pitchFamily="34" charset="-122"/>
                 <a:cs typeface="Be Vietnam Pro" pitchFamily="34" charset="-120"/>
               </a:rPr>
-              <a:t> 2026-10-18.</a:t>
-            </a:r>
-            <a:r>
-              <a:rPr lang="en-US" sz="2100" dirty="0" spc="0" kern="0">
+              <a:t> 2026-10-19. Hình minh</a:t>
+            </a:r>
+            <a:r>
+              <a:rPr lang="en-US" sz="2100" dirty="0" spc="-5" kern="0">
                 <a:solidFill>
                   <a:srgbClr val="C4C8D6"/>
                 </a:solidFill>
@@ -21258,10 +21082,10 @@
                 <a:ea typeface="Be Vietnam Pro" pitchFamily="34" charset="-122"/>
                 <a:cs typeface="Be Vietnam Pro" pitchFamily="34" charset="-120"/>
               </a:rPr>
-              <a:t> Hình</a:t>
-            </a:r>
-            <a:r>
-              <a:rPr lang="en-US" sz="2100" dirty="0" spc="1" kern="0">
+              <a:t> họa</a:t>
+            </a:r>
+            <a:r>
+              <a:rPr lang="en-US" sz="2100" dirty="0" spc="-4" kern="0">
                 <a:solidFill>
                   <a:srgbClr val="C4C8D6"/>
                 </a:solidFill>
@@ -21269,10 +21093,10 @@
                 <a:ea typeface="Be Vietnam Pro" pitchFamily="34" charset="-122"/>
                 <a:cs typeface="Be Vietnam Pro" pitchFamily="34" charset="-120"/>
               </a:rPr>
-              <a:t> minh</a:t>
-            </a:r>
-            <a:r>
-              <a:rPr lang="en-US" sz="2100" dirty="0" spc="-6" kern="0">
+              <a:t> là</a:t>
+            </a:r>
+            <a:r>
+              <a:rPr lang="en-US" sz="2100" dirty="0" spc="-3" kern="0">
                 <a:solidFill>
                   <a:srgbClr val="C4C8D6"/>
                 </a:solidFill>
@@ -21280,32 +21104,10 @@
                 <a:ea typeface="Be Vietnam Pro" pitchFamily="34" charset="-122"/>
                 <a:cs typeface="Be Vietnam Pro" pitchFamily="34" charset="-120"/>
               </a:rPr>
-              <a:t> họa</a:t>
-            </a:r>
-            <a:r>
-              <a:rPr lang="en-US" sz="2100" dirty="0" spc="-3" kern="0">
-                <a:solidFill>
-                  <a:srgbClr val="C4C8D6"/>
-                </a:solidFill>
-                <a:latin typeface="Be Vietnam Pro" pitchFamily="34" charset="0"/>
-                <a:ea typeface="Be Vietnam Pro" pitchFamily="34" charset="-122"/>
-                <a:cs typeface="Be Vietnam Pro" pitchFamily="34" charset="-120"/>
-              </a:rPr>
-              <a:t> là</a:t>
-            </a:r>
-            <a:r>
-              <a:rPr lang="en-US" sz="2100" dirty="0" spc="-4" kern="0">
-                <a:solidFill>
-                  <a:srgbClr val="C4C8D6"/>
-                </a:solidFill>
-                <a:latin typeface="Be Vietnam Pro" pitchFamily="34" charset="0"/>
-                <a:ea typeface="Be Vietnam Pro" pitchFamily="34" charset="-122"/>
-                <a:cs typeface="Be Vietnam Pro" pitchFamily="34" charset="-120"/>
-              </a:rPr>
               <a:t> thiết</a:t>
             </a:r>
             <a:r>
-              <a:rPr lang="en-US" sz="2100" dirty="0" spc="-30" kern="0">
+              <a:rPr lang="en-US" sz="2100" dirty="0" spc="-31" kern="0">
                 <a:solidFill>
                   <a:srgbClr val="C4C8D6"/>
                 </a:solidFill>

</xml_diff>